<commit_message>
replace final presentation deck
</commit_message>
<xml_diff>
--- a/cs1090b_ms4_presentation_group12.pptx
+++ b/cs1090b_ms4_presentation_group12.pptx
@@ -870,7 +870,7 @@
   <p:cSld>
     <p:spTree>
       <p:nvGrpSpPr>
-        <p:cNvPr id="311" name="Shape 311"/>
+        <p:cNvPr id="330" name="Shape 330"/>
         <p:cNvGrpSpPr/>
         <p:nvPr/>
       </p:nvGrpSpPr>
@@ -884,7 +884,7 @@
       </p:grpSpPr>
       <p:sp>
         <p:nvSpPr>
-          <p:cNvPr id="312" name="Google Shape;312;g3e0a59985dd_6_315:notes"/>
+          <p:cNvPr id="331" name="Google Shape;331;g3e0a59985dd_6_315:notes"/>
           <p:cNvSpPr/>
           <p:nvPr>
             <p:ph idx="2" type="sldImg"/>
@@ -929,7 +929,7 @@
       </p:sp>
       <p:sp>
         <p:nvSpPr>
-          <p:cNvPr id="313" name="Google Shape;313;g3e0a59985dd_6_315:notes"/>
+          <p:cNvPr id="332" name="Google Shape;332;g3e0a59985dd_6_315:notes"/>
           <p:cNvSpPr txBox="1"/>
           <p:nvPr>
             <p:ph idx="1" type="body"/>
@@ -972,7 +972,7 @@
       </p:sp>
       <p:sp>
         <p:nvSpPr>
-          <p:cNvPr id="314" name="Google Shape;314;g3e0a59985dd_6_315:notes"/>
+          <p:cNvPr id="333" name="Google Shape;333;g3e0a59985dd_6_315:notes"/>
           <p:cNvSpPr txBox="1"/>
           <p:nvPr>
             <p:ph idx="12" type="sldNum"/>
@@ -1027,7 +1027,7 @@
   <p:cSld>
     <p:spTree>
       <p:nvGrpSpPr>
-        <p:cNvPr id="335" name="Shape 335"/>
+        <p:cNvPr id="354" name="Shape 354"/>
         <p:cNvGrpSpPr/>
         <p:nvPr/>
       </p:nvGrpSpPr>
@@ -1041,7 +1041,7 @@
       </p:grpSpPr>
       <p:sp>
         <p:nvSpPr>
-          <p:cNvPr id="336" name="Google Shape;336;g3e0a59985dd_6_338:notes"/>
+          <p:cNvPr id="355" name="Google Shape;355;g3e0a59985dd_6_338:notes"/>
           <p:cNvSpPr/>
           <p:nvPr>
             <p:ph idx="2" type="sldImg"/>
@@ -1086,7 +1086,7 @@
       </p:sp>
       <p:sp>
         <p:nvSpPr>
-          <p:cNvPr id="337" name="Google Shape;337;g3e0a59985dd_6_338:notes"/>
+          <p:cNvPr id="356" name="Google Shape;356;g3e0a59985dd_6_338:notes"/>
           <p:cNvSpPr txBox="1"/>
           <p:nvPr>
             <p:ph idx="1" type="body"/>
@@ -1129,7 +1129,7 @@
       </p:sp>
       <p:sp>
         <p:nvSpPr>
-          <p:cNvPr id="338" name="Google Shape;338;g3e0a59985dd_6_338:notes"/>
+          <p:cNvPr id="357" name="Google Shape;357;g3e0a59985dd_6_338:notes"/>
           <p:cNvSpPr txBox="1"/>
           <p:nvPr>
             <p:ph idx="12" type="sldNum"/>
@@ -1184,7 +1184,7 @@
   <p:cSld>
     <p:spTree>
       <p:nvGrpSpPr>
-        <p:cNvPr id="350" name="Shape 350"/>
+        <p:cNvPr id="369" name="Shape 369"/>
         <p:cNvGrpSpPr/>
         <p:nvPr/>
       </p:nvGrpSpPr>
@@ -1198,7 +1198,7 @@
       </p:grpSpPr>
       <p:sp>
         <p:nvSpPr>
-          <p:cNvPr id="351" name="Google Shape;351;g3e0a59985dd_6_352:notes"/>
+          <p:cNvPr id="370" name="Google Shape;370;g3e0a59985dd_6_352:notes"/>
           <p:cNvSpPr/>
           <p:nvPr>
             <p:ph idx="2" type="sldImg"/>
@@ -1243,7 +1243,7 @@
       </p:sp>
       <p:sp>
         <p:nvSpPr>
-          <p:cNvPr id="352" name="Google Shape;352;g3e0a59985dd_6_352:notes"/>
+          <p:cNvPr id="371" name="Google Shape;371;g3e0a59985dd_6_352:notes"/>
           <p:cNvSpPr txBox="1"/>
           <p:nvPr>
             <p:ph idx="1" type="body"/>
@@ -1286,7 +1286,7 @@
       </p:sp>
       <p:sp>
         <p:nvSpPr>
-          <p:cNvPr id="353" name="Google Shape;353;g3e0a59985dd_6_352:notes"/>
+          <p:cNvPr id="372" name="Google Shape;372;g3e0a59985dd_6_352:notes"/>
           <p:cNvSpPr txBox="1"/>
           <p:nvPr>
             <p:ph idx="12" type="sldNum"/>
@@ -1341,7 +1341,7 @@
   <p:cSld>
     <p:spTree>
       <p:nvGrpSpPr>
-        <p:cNvPr id="416" name="Shape 416"/>
+        <p:cNvPr id="435" name="Shape 435"/>
         <p:cNvGrpSpPr/>
         <p:nvPr/>
       </p:nvGrpSpPr>
@@ -1355,7 +1355,7 @@
       </p:grpSpPr>
       <p:sp>
         <p:nvSpPr>
-          <p:cNvPr id="417" name="Google Shape;417;g3e0a59985dd_6_421:notes"/>
+          <p:cNvPr id="436" name="Google Shape;436;g3e0a59985dd_6_421:notes"/>
           <p:cNvSpPr/>
           <p:nvPr>
             <p:ph idx="2" type="sldImg"/>
@@ -1400,7 +1400,7 @@
       </p:sp>
       <p:sp>
         <p:nvSpPr>
-          <p:cNvPr id="418" name="Google Shape;418;g3e0a59985dd_6_421:notes"/>
+          <p:cNvPr id="437" name="Google Shape;437;g3e0a59985dd_6_421:notes"/>
           <p:cNvSpPr txBox="1"/>
           <p:nvPr>
             <p:ph idx="1" type="body"/>
@@ -1409,7 +1409,7 @@
         <p:spPr>
           <a:xfrm>
             <a:off x="914400" y="4400550"/>
-            <a:ext cx="7315200" cy="3600450"/>
+            <a:ext cx="7315200" cy="3600600"/>
           </a:xfrm>
           <a:prstGeom prst="rect">
             <a:avLst/>
@@ -1443,7 +1443,7 @@
       </p:sp>
       <p:sp>
         <p:nvSpPr>
-          <p:cNvPr id="419" name="Google Shape;419;g3e0a59985dd_6_421:notes"/>
+          <p:cNvPr id="438" name="Google Shape;438;g3e0a59985dd_6_421:notes"/>
           <p:cNvSpPr txBox="1"/>
           <p:nvPr>
             <p:ph idx="12" type="sldNum"/>
@@ -1452,7 +1452,7 @@
         <p:spPr>
           <a:xfrm>
             <a:off x="5179484" y="8685213"/>
-            <a:ext cx="3962400" cy="458787"/>
+            <a:ext cx="3962400" cy="458700"/>
           </a:xfrm>
           <a:prstGeom prst="rect">
             <a:avLst/>
@@ -1498,7 +1498,7 @@
   <p:cSld>
     <p:spTree>
       <p:nvGrpSpPr>
-        <p:cNvPr id="446" name="Shape 446"/>
+        <p:cNvPr id="489" name="Shape 489"/>
         <p:cNvGrpSpPr/>
         <p:nvPr/>
       </p:nvGrpSpPr>
@@ -1512,7 +1512,7 @@
       </p:grpSpPr>
       <p:sp>
         <p:nvSpPr>
-          <p:cNvPr id="447" name="Google Shape;447;g3e0a59985dd_6_449:notes"/>
+          <p:cNvPr id="490" name="Google Shape;490;g3e0a59985dd_6_449:notes"/>
           <p:cNvSpPr/>
           <p:nvPr>
             <p:ph idx="2" type="sldImg"/>
@@ -1557,7 +1557,7 @@
       </p:sp>
       <p:sp>
         <p:nvSpPr>
-          <p:cNvPr id="448" name="Google Shape;448;g3e0a59985dd_6_449:notes"/>
+          <p:cNvPr id="491" name="Google Shape;491;g3e0a59985dd_6_449:notes"/>
           <p:cNvSpPr txBox="1"/>
           <p:nvPr>
             <p:ph idx="1" type="body"/>
@@ -1600,7 +1600,7 @@
       </p:sp>
       <p:sp>
         <p:nvSpPr>
-          <p:cNvPr id="449" name="Google Shape;449;g3e0a59985dd_6_449:notes"/>
+          <p:cNvPr id="492" name="Google Shape;492;g3e0a59985dd_6_449:notes"/>
           <p:cNvSpPr txBox="1"/>
           <p:nvPr>
             <p:ph idx="12" type="sldNum"/>
@@ -2754,7 +2754,7 @@
   <p:cSld>
     <p:spTree>
       <p:nvGrpSpPr>
-        <p:cNvPr id="271" name="Shape 271"/>
+        <p:cNvPr id="290" name="Shape 290"/>
         <p:cNvGrpSpPr/>
         <p:nvPr/>
       </p:nvGrpSpPr>
@@ -2768,7 +2768,7 @@
       </p:grpSpPr>
       <p:sp>
         <p:nvSpPr>
-          <p:cNvPr id="272" name="Google Shape;272;g3e0a59985dd_6_271:notes"/>
+          <p:cNvPr id="291" name="Google Shape;291;g3e0a59985dd_6_271:notes"/>
           <p:cNvSpPr/>
           <p:nvPr>
             <p:ph idx="2" type="sldImg"/>
@@ -2813,7 +2813,7 @@
       </p:sp>
       <p:sp>
         <p:nvSpPr>
-          <p:cNvPr id="273" name="Google Shape;273;g3e0a59985dd_6_271:notes"/>
+          <p:cNvPr id="292" name="Google Shape;292;g3e0a59985dd_6_271:notes"/>
           <p:cNvSpPr txBox="1"/>
           <p:nvPr>
             <p:ph idx="1" type="body"/>
@@ -2856,7 +2856,7 @@
       </p:sp>
       <p:sp>
         <p:nvSpPr>
-          <p:cNvPr id="274" name="Google Shape;274;g3e0a59985dd_6_271:notes"/>
+          <p:cNvPr id="293" name="Google Shape;293;g3e0a59985dd_6_271:notes"/>
           <p:cNvSpPr txBox="1"/>
           <p:nvPr>
             <p:ph idx="12" type="sldNum"/>
@@ -4185,7 +4185,7 @@
     </p:bg>
     <p:spTree>
       <p:nvGrpSpPr>
-        <p:cNvPr id="315" name="Shape 315"/>
+        <p:cNvPr id="334" name="Shape 334"/>
         <p:cNvGrpSpPr/>
         <p:nvPr/>
       </p:nvGrpSpPr>
@@ -4199,7 +4199,7 @@
       </p:grpSpPr>
       <p:sp>
         <p:nvSpPr>
-          <p:cNvPr id="316" name="Google Shape;316;p12"/>
+          <p:cNvPr id="335" name="Google Shape;335;p12"/>
           <p:cNvSpPr/>
           <p:nvPr/>
         </p:nvSpPr>
@@ -4248,7 +4248,7 @@
       </p:sp>
       <p:sp>
         <p:nvSpPr>
-          <p:cNvPr id="317" name="Google Shape;317;p12"/>
+          <p:cNvPr id="336" name="Google Shape;336;p12"/>
           <p:cNvSpPr/>
           <p:nvPr/>
         </p:nvSpPr>
@@ -4310,7 +4310,7 @@
       </p:sp>
       <p:sp>
         <p:nvSpPr>
-          <p:cNvPr id="318" name="Google Shape;318;p12"/>
+          <p:cNvPr id="337" name="Google Shape;337;p12"/>
           <p:cNvSpPr/>
           <p:nvPr/>
         </p:nvSpPr>
@@ -4372,7 +4372,7 @@
       </p:sp>
       <p:sp>
         <p:nvSpPr>
-          <p:cNvPr id="319" name="Google Shape;319;p12"/>
+          <p:cNvPr id="338" name="Google Shape;338;p12"/>
           <p:cNvSpPr/>
           <p:nvPr/>
         </p:nvSpPr>
@@ -4434,7 +4434,7 @@
       </p:sp>
       <p:sp>
         <p:nvSpPr>
-          <p:cNvPr id="320" name="Google Shape;320;p12"/>
+          <p:cNvPr id="339" name="Google Shape;339;p12"/>
           <p:cNvSpPr/>
           <p:nvPr/>
         </p:nvSpPr>
@@ -4483,7 +4483,7 @@
       </p:sp>
       <p:pic>
         <p:nvPicPr>
-          <p:cNvPr descr="preencoded.png" id="321" name="Google Shape;321;p12"/>
+          <p:cNvPr descr="preencoded.png" id="340" name="Google Shape;340;p12"/>
           <p:cNvPicPr preferRelativeResize="0"/>
           <p:nvPr/>
         </p:nvPicPr>
@@ -4510,7 +4510,7 @@
       </p:pic>
       <p:sp>
         <p:nvSpPr>
-          <p:cNvPr id="322" name="Google Shape;322;p12"/>
+          <p:cNvPr id="341" name="Google Shape;341;p12"/>
           <p:cNvSpPr/>
           <p:nvPr/>
         </p:nvSpPr>
@@ -4572,7 +4572,7 @@
       </p:sp>
       <p:sp>
         <p:nvSpPr>
-          <p:cNvPr id="323" name="Google Shape;323;p12"/>
+          <p:cNvPr id="342" name="Google Shape;342;p12"/>
           <p:cNvSpPr/>
           <p:nvPr/>
         </p:nvSpPr>
@@ -4621,7 +4621,7 @@
       </p:sp>
       <p:sp>
         <p:nvSpPr>
-          <p:cNvPr id="324" name="Google Shape;324;p12"/>
+          <p:cNvPr id="343" name="Google Shape;343;p12"/>
           <p:cNvSpPr/>
           <p:nvPr/>
         </p:nvSpPr>
@@ -4664,7 +4664,7 @@
       </p:sp>
       <p:sp>
         <p:nvSpPr>
-          <p:cNvPr id="325" name="Google Shape;325;p12"/>
+          <p:cNvPr id="344" name="Google Shape;344;p12"/>
           <p:cNvSpPr/>
           <p:nvPr/>
         </p:nvSpPr>
@@ -4726,7 +4726,7 @@
       </p:sp>
       <p:sp>
         <p:nvSpPr>
-          <p:cNvPr id="326" name="Google Shape;326;p12"/>
+          <p:cNvPr id="345" name="Google Shape;345;p12"/>
           <p:cNvSpPr/>
           <p:nvPr/>
         </p:nvSpPr>
@@ -4788,7 +4788,7 @@
       </p:sp>
       <p:sp>
         <p:nvSpPr>
-          <p:cNvPr id="327" name="Google Shape;327;p12"/>
+          <p:cNvPr id="346" name="Google Shape;346;p12"/>
           <p:cNvSpPr/>
           <p:nvPr/>
         </p:nvSpPr>
@@ -4837,7 +4837,7 @@
       </p:sp>
       <p:pic>
         <p:nvPicPr>
-          <p:cNvPr id="328" name="Google Shape;328;p12"/>
+          <p:cNvPr id="347" name="Google Shape;347;p12"/>
           <p:cNvPicPr preferRelativeResize="0"/>
           <p:nvPr/>
         </p:nvPicPr>
@@ -4864,7 +4864,7 @@
       </p:pic>
       <p:sp>
         <p:nvSpPr>
-          <p:cNvPr id="329" name="Google Shape;329;p12"/>
+          <p:cNvPr id="348" name="Google Shape;348;p12"/>
           <p:cNvSpPr/>
           <p:nvPr/>
         </p:nvSpPr>
@@ -4926,7 +4926,7 @@
       </p:sp>
       <p:sp>
         <p:nvSpPr>
-          <p:cNvPr id="330" name="Google Shape;330;p12"/>
+          <p:cNvPr id="349" name="Google Shape;349;p12"/>
           <p:cNvSpPr/>
           <p:nvPr/>
         </p:nvSpPr>
@@ -4988,7 +4988,7 @@
       </p:sp>
       <p:sp>
         <p:nvSpPr>
-          <p:cNvPr id="331" name="Google Shape;331;p12"/>
+          <p:cNvPr id="350" name="Google Shape;350;p12"/>
           <p:cNvSpPr/>
           <p:nvPr/>
         </p:nvSpPr>
@@ -5037,7 +5037,7 @@
       </p:sp>
       <p:pic>
         <p:nvPicPr>
-          <p:cNvPr id="332" name="Google Shape;332;p12"/>
+          <p:cNvPr id="351" name="Google Shape;351;p12"/>
           <p:cNvPicPr preferRelativeResize="0"/>
           <p:nvPr/>
         </p:nvPicPr>
@@ -5064,7 +5064,7 @@
       </p:pic>
       <p:sp>
         <p:nvSpPr>
-          <p:cNvPr id="333" name="Google Shape;333;p12"/>
+          <p:cNvPr id="352" name="Google Shape;352;p12"/>
           <p:cNvSpPr/>
           <p:nvPr/>
         </p:nvSpPr>
@@ -5126,7 +5126,7 @@
       </p:sp>
       <p:sp>
         <p:nvSpPr>
-          <p:cNvPr id="334" name="Google Shape;334;p12"/>
+          <p:cNvPr id="353" name="Google Shape;353;p12"/>
           <p:cNvSpPr/>
           <p:nvPr/>
         </p:nvSpPr>
@@ -5206,7 +5206,7 @@
     </p:bg>
     <p:spTree>
       <p:nvGrpSpPr>
-        <p:cNvPr id="339" name="Shape 339"/>
+        <p:cNvPr id="358" name="Shape 358"/>
         <p:cNvGrpSpPr/>
         <p:nvPr/>
       </p:nvGrpSpPr>
@@ -5220,7 +5220,7 @@
       </p:grpSpPr>
       <p:sp>
         <p:nvSpPr>
-          <p:cNvPr id="340" name="Google Shape;340;p13"/>
+          <p:cNvPr id="359" name="Google Shape;359;p13"/>
           <p:cNvSpPr/>
           <p:nvPr/>
         </p:nvSpPr>
@@ -5269,7 +5269,7 @@
       </p:sp>
       <p:sp>
         <p:nvSpPr>
-          <p:cNvPr id="341" name="Google Shape;341;p13"/>
+          <p:cNvPr id="360" name="Google Shape;360;p13"/>
           <p:cNvSpPr/>
           <p:nvPr/>
         </p:nvSpPr>
@@ -5331,7 +5331,7 @@
       </p:sp>
       <p:sp>
         <p:nvSpPr>
-          <p:cNvPr id="342" name="Google Shape;342;p13"/>
+          <p:cNvPr id="361" name="Google Shape;361;p13"/>
           <p:cNvSpPr/>
           <p:nvPr/>
         </p:nvSpPr>
@@ -5393,7 +5393,7 @@
       </p:sp>
       <p:sp>
         <p:nvSpPr>
-          <p:cNvPr id="343" name="Google Shape;343;p13"/>
+          <p:cNvPr id="362" name="Google Shape;362;p13"/>
           <p:cNvSpPr/>
           <p:nvPr/>
         </p:nvSpPr>
@@ -5455,7 +5455,7 @@
       </p:sp>
       <p:sp>
         <p:nvSpPr>
-          <p:cNvPr id="344" name="Google Shape;344;p13"/>
+          <p:cNvPr id="363" name="Google Shape;363;p13"/>
           <p:cNvSpPr/>
           <p:nvPr/>
         </p:nvSpPr>
@@ -5504,7 +5504,7 @@
       </p:sp>
       <p:pic>
         <p:nvPicPr>
-          <p:cNvPr descr="preencoded.png" id="345" name="Google Shape;345;p13"/>
+          <p:cNvPr descr="preencoded.png" id="364" name="Google Shape;364;p13"/>
           <p:cNvPicPr preferRelativeResize="0"/>
           <p:nvPr/>
         </p:nvPicPr>
@@ -5531,7 +5531,7 @@
       </p:pic>
       <p:sp>
         <p:nvSpPr>
-          <p:cNvPr id="346" name="Google Shape;346;p13"/>
+          <p:cNvPr id="365" name="Google Shape;365;p13"/>
           <p:cNvSpPr/>
           <p:nvPr/>
         </p:nvSpPr>
@@ -5593,7 +5593,7 @@
       </p:sp>
       <p:sp>
         <p:nvSpPr>
-          <p:cNvPr id="347" name="Google Shape;347;p13"/>
+          <p:cNvPr id="366" name="Google Shape;366;p13"/>
           <p:cNvSpPr/>
           <p:nvPr/>
         </p:nvSpPr>
@@ -5642,7 +5642,7 @@
       </p:sp>
       <p:sp>
         <p:nvSpPr>
-          <p:cNvPr id="348" name="Google Shape;348;p13"/>
+          <p:cNvPr id="367" name="Google Shape;367;p13"/>
           <p:cNvSpPr/>
           <p:nvPr/>
         </p:nvSpPr>
@@ -5691,7 +5691,7 @@
       </p:sp>
       <p:sp>
         <p:nvSpPr>
-          <p:cNvPr id="349" name="Google Shape;349;p13"/>
+          <p:cNvPr id="368" name="Google Shape;368;p13"/>
           <p:cNvSpPr/>
           <p:nvPr/>
         </p:nvSpPr>
@@ -5771,7 +5771,7 @@
     </p:bg>
     <p:spTree>
       <p:nvGrpSpPr>
-        <p:cNvPr id="354" name="Shape 354"/>
+        <p:cNvPr id="373" name="Shape 373"/>
         <p:cNvGrpSpPr/>
         <p:nvPr/>
       </p:nvGrpSpPr>
@@ -5785,7 +5785,7 @@
       </p:grpSpPr>
       <p:sp>
         <p:nvSpPr>
-          <p:cNvPr id="355" name="Google Shape;355;p14"/>
+          <p:cNvPr id="374" name="Google Shape;374;p14"/>
           <p:cNvSpPr/>
           <p:nvPr/>
         </p:nvSpPr>
@@ -5834,7 +5834,7 @@
       </p:sp>
       <p:sp>
         <p:nvSpPr>
-          <p:cNvPr id="356" name="Google Shape;356;p14"/>
+          <p:cNvPr id="375" name="Google Shape;375;p14"/>
           <p:cNvSpPr/>
           <p:nvPr/>
         </p:nvSpPr>
@@ -5897,7 +5897,7 @@
       </p:sp>
       <p:sp>
         <p:nvSpPr>
-          <p:cNvPr id="357" name="Google Shape;357;p14"/>
+          <p:cNvPr id="376" name="Google Shape;376;p14"/>
           <p:cNvSpPr/>
           <p:nvPr/>
         </p:nvSpPr>
@@ -5960,7 +5960,7 @@
       </p:sp>
       <p:sp>
         <p:nvSpPr>
-          <p:cNvPr id="358" name="Google Shape;358;p14"/>
+          <p:cNvPr id="377" name="Google Shape;377;p14"/>
           <p:cNvSpPr/>
           <p:nvPr/>
         </p:nvSpPr>
@@ -6047,7 +6047,7 @@
       </p:sp>
       <p:sp>
         <p:nvSpPr>
-          <p:cNvPr id="359" name="Google Shape;359;p14"/>
+          <p:cNvPr id="378" name="Google Shape;378;p14"/>
           <p:cNvSpPr/>
           <p:nvPr/>
         </p:nvSpPr>
@@ -6096,7 +6096,7 @@
       </p:sp>
       <p:sp>
         <p:nvSpPr>
-          <p:cNvPr id="360" name="Google Shape;360;p14"/>
+          <p:cNvPr id="379" name="Google Shape;379;p14"/>
           <p:cNvSpPr/>
           <p:nvPr/>
         </p:nvSpPr>
@@ -6145,7 +6145,7 @@
       </p:sp>
       <p:sp>
         <p:nvSpPr>
-          <p:cNvPr id="361" name="Google Shape;361;p14"/>
+          <p:cNvPr id="380" name="Google Shape;380;p14"/>
           <p:cNvSpPr/>
           <p:nvPr/>
         </p:nvSpPr>
@@ -6208,7 +6208,7 @@
       </p:sp>
       <p:sp>
         <p:nvSpPr>
-          <p:cNvPr id="362" name="Google Shape;362;p14"/>
+          <p:cNvPr id="381" name="Google Shape;381;p14"/>
           <p:cNvSpPr/>
           <p:nvPr/>
         </p:nvSpPr>
@@ -6264,7 +6264,7 @@
       </p:sp>
       <p:sp>
         <p:nvSpPr>
-          <p:cNvPr id="363" name="Google Shape;363;p14"/>
+          <p:cNvPr id="382" name="Google Shape;382;p14"/>
           <p:cNvSpPr/>
           <p:nvPr/>
         </p:nvSpPr>
@@ -6327,7 +6327,7 @@
       </p:sp>
       <p:sp>
         <p:nvSpPr>
-          <p:cNvPr id="364" name="Google Shape;364;p14"/>
+          <p:cNvPr id="383" name="Google Shape;383;p14"/>
           <p:cNvSpPr/>
           <p:nvPr/>
         </p:nvSpPr>
@@ -6427,7 +6427,7 @@
       </p:sp>
       <p:sp>
         <p:nvSpPr>
-          <p:cNvPr id="365" name="Google Shape;365;p14"/>
+          <p:cNvPr id="384" name="Google Shape;384;p14"/>
           <p:cNvSpPr/>
           <p:nvPr/>
         </p:nvSpPr>
@@ -6489,7 +6489,7 @@
       </p:sp>
       <p:sp>
         <p:nvSpPr>
-          <p:cNvPr id="366" name="Google Shape;366;p14"/>
+          <p:cNvPr id="385" name="Google Shape;385;p14"/>
           <p:cNvSpPr/>
           <p:nvPr/>
         </p:nvSpPr>
@@ -6538,7 +6538,7 @@
       </p:sp>
       <p:sp>
         <p:nvSpPr>
-          <p:cNvPr id="367" name="Google Shape;367;p14"/>
+          <p:cNvPr id="386" name="Google Shape;386;p14"/>
           <p:cNvSpPr/>
           <p:nvPr/>
         </p:nvSpPr>
@@ -6601,7 +6601,7 @@
       </p:sp>
       <p:sp>
         <p:nvSpPr>
-          <p:cNvPr id="368" name="Google Shape;368;p14"/>
+          <p:cNvPr id="387" name="Google Shape;387;p14"/>
           <p:cNvSpPr/>
           <p:nvPr/>
         </p:nvSpPr>
@@ -6657,7 +6657,7 @@
       </p:sp>
       <p:sp>
         <p:nvSpPr>
-          <p:cNvPr id="369" name="Google Shape;369;p14"/>
+          <p:cNvPr id="388" name="Google Shape;388;p14"/>
           <p:cNvSpPr/>
           <p:nvPr/>
         </p:nvSpPr>
@@ -6757,7 +6757,7 @@
       </p:sp>
       <p:sp>
         <p:nvSpPr>
-          <p:cNvPr id="370" name="Google Shape;370;p14"/>
+          <p:cNvPr id="389" name="Google Shape;389;p14"/>
           <p:cNvSpPr/>
           <p:nvPr/>
         </p:nvSpPr>
@@ -6857,7 +6857,7 @@
       </p:sp>
       <p:sp>
         <p:nvSpPr>
-          <p:cNvPr id="371" name="Google Shape;371;p14"/>
+          <p:cNvPr id="390" name="Google Shape;390;p14"/>
           <p:cNvSpPr/>
           <p:nvPr/>
         </p:nvSpPr>
@@ -6919,7 +6919,7 @@
       </p:sp>
       <p:sp>
         <p:nvSpPr>
-          <p:cNvPr id="372" name="Google Shape;372;p14"/>
+          <p:cNvPr id="391" name="Google Shape;391;p14"/>
           <p:cNvSpPr/>
           <p:nvPr/>
         </p:nvSpPr>
@@ -6968,7 +6968,7 @@
       </p:sp>
       <p:sp>
         <p:nvSpPr>
-          <p:cNvPr id="373" name="Google Shape;373;p14"/>
+          <p:cNvPr id="392" name="Google Shape;392;p14"/>
           <p:cNvSpPr/>
           <p:nvPr/>
         </p:nvSpPr>
@@ -7031,7 +7031,7 @@
       </p:sp>
       <p:sp>
         <p:nvSpPr>
-          <p:cNvPr id="374" name="Google Shape;374;p14"/>
+          <p:cNvPr id="393" name="Google Shape;393;p14"/>
           <p:cNvSpPr/>
           <p:nvPr/>
         </p:nvSpPr>
@@ -7087,7 +7087,7 @@
       </p:sp>
       <p:sp>
         <p:nvSpPr>
-          <p:cNvPr id="375" name="Google Shape;375;p14"/>
+          <p:cNvPr id="394" name="Google Shape;394;p14"/>
           <p:cNvSpPr/>
           <p:nvPr/>
         </p:nvSpPr>
@@ -7187,7 +7187,7 @@
       </p:sp>
       <p:sp>
         <p:nvSpPr>
-          <p:cNvPr id="376" name="Google Shape;376;p14"/>
+          <p:cNvPr id="395" name="Google Shape;395;p14"/>
           <p:cNvSpPr/>
           <p:nvPr/>
         </p:nvSpPr>
@@ -7249,7 +7249,7 @@
       </p:sp>
       <p:sp>
         <p:nvSpPr>
-          <p:cNvPr id="377" name="Google Shape;377;p14"/>
+          <p:cNvPr id="396" name="Google Shape;396;p14"/>
           <p:cNvSpPr/>
           <p:nvPr/>
         </p:nvSpPr>
@@ -7298,7 +7298,7 @@
       </p:sp>
       <p:sp>
         <p:nvSpPr>
-          <p:cNvPr id="378" name="Google Shape;378;p14"/>
+          <p:cNvPr id="397" name="Google Shape;397;p14"/>
           <p:cNvSpPr/>
           <p:nvPr/>
         </p:nvSpPr>
@@ -7361,7 +7361,7 @@
       </p:sp>
       <p:sp>
         <p:nvSpPr>
-          <p:cNvPr id="379" name="Google Shape;379;p14"/>
+          <p:cNvPr id="398" name="Google Shape;398;p14"/>
           <p:cNvSpPr/>
           <p:nvPr/>
         </p:nvSpPr>
@@ -7417,7 +7417,7 @@
       </p:sp>
       <p:sp>
         <p:nvSpPr>
-          <p:cNvPr id="380" name="Google Shape;380;p14"/>
+          <p:cNvPr id="399" name="Google Shape;399;p14"/>
           <p:cNvSpPr/>
           <p:nvPr/>
         </p:nvSpPr>
@@ -7517,7 +7517,7 @@
       </p:sp>
       <p:sp>
         <p:nvSpPr>
-          <p:cNvPr id="381" name="Google Shape;381;p14"/>
+          <p:cNvPr id="400" name="Google Shape;400;p14"/>
           <p:cNvSpPr/>
           <p:nvPr/>
         </p:nvSpPr>
@@ -7617,7 +7617,7 @@
       </p:sp>
       <p:sp>
         <p:nvSpPr>
-          <p:cNvPr id="382" name="Google Shape;382;p14"/>
+          <p:cNvPr id="401" name="Google Shape;401;p14"/>
           <p:cNvSpPr/>
           <p:nvPr/>
         </p:nvSpPr>
@@ -7679,7 +7679,7 @@
       </p:sp>
       <p:sp>
         <p:nvSpPr>
-          <p:cNvPr id="383" name="Google Shape;383;p14"/>
+          <p:cNvPr id="402" name="Google Shape;402;p14"/>
           <p:cNvSpPr/>
           <p:nvPr/>
         </p:nvSpPr>
@@ -7728,7 +7728,7 @@
       </p:sp>
       <p:sp>
         <p:nvSpPr>
-          <p:cNvPr id="384" name="Google Shape;384;p14"/>
+          <p:cNvPr id="403" name="Google Shape;403;p14"/>
           <p:cNvSpPr/>
           <p:nvPr/>
         </p:nvSpPr>
@@ -7791,7 +7791,7 @@
       </p:sp>
       <p:sp>
         <p:nvSpPr>
-          <p:cNvPr id="385" name="Google Shape;385;p14"/>
+          <p:cNvPr id="404" name="Google Shape;404;p14"/>
           <p:cNvSpPr/>
           <p:nvPr/>
         </p:nvSpPr>
@@ -7847,7 +7847,7 @@
       </p:sp>
       <p:sp>
         <p:nvSpPr>
-          <p:cNvPr id="386" name="Google Shape;386;p14"/>
+          <p:cNvPr id="405" name="Google Shape;405;p14"/>
           <p:cNvSpPr/>
           <p:nvPr/>
         </p:nvSpPr>
@@ -7910,7 +7910,7 @@
       </p:sp>
       <p:sp>
         <p:nvSpPr>
-          <p:cNvPr id="387" name="Google Shape;387;p14"/>
+          <p:cNvPr id="406" name="Google Shape;406;p14"/>
           <p:cNvSpPr/>
           <p:nvPr/>
         </p:nvSpPr>
@@ -8034,7 +8034,7 @@
       </p:sp>
       <p:sp>
         <p:nvSpPr>
-          <p:cNvPr id="388" name="Google Shape;388;p14"/>
+          <p:cNvPr id="407" name="Google Shape;407;p14"/>
           <p:cNvSpPr/>
           <p:nvPr/>
         </p:nvSpPr>
@@ -8083,7 +8083,7 @@
       </p:sp>
       <p:sp>
         <p:nvSpPr>
-          <p:cNvPr id="389" name="Google Shape;389;p14"/>
+          <p:cNvPr id="408" name="Google Shape;408;p14"/>
           <p:cNvSpPr/>
           <p:nvPr/>
         </p:nvSpPr>
@@ -8146,7 +8146,7 @@
       </p:sp>
       <p:sp>
         <p:nvSpPr>
-          <p:cNvPr id="390" name="Google Shape;390;p14"/>
+          <p:cNvPr id="409" name="Google Shape;409;p14"/>
           <p:cNvSpPr/>
           <p:nvPr/>
         </p:nvSpPr>
@@ -8195,7 +8195,7 @@
       </p:sp>
       <p:sp>
         <p:nvSpPr>
-          <p:cNvPr id="391" name="Google Shape;391;p14"/>
+          <p:cNvPr id="410" name="Google Shape;410;p14"/>
           <p:cNvSpPr/>
           <p:nvPr/>
         </p:nvSpPr>
@@ -8258,7 +8258,7 @@
       </p:sp>
       <p:sp>
         <p:nvSpPr>
-          <p:cNvPr id="392" name="Google Shape;392;p14"/>
+          <p:cNvPr id="411" name="Google Shape;411;p14"/>
           <p:cNvSpPr/>
           <p:nvPr/>
         </p:nvSpPr>
@@ -8321,7 +8321,7 @@
       </p:sp>
       <p:sp>
         <p:nvSpPr>
-          <p:cNvPr id="393" name="Google Shape;393;p14"/>
+          <p:cNvPr id="412" name="Google Shape;412;p14"/>
           <p:cNvSpPr/>
           <p:nvPr/>
         </p:nvSpPr>
@@ -8384,7 +8384,7 @@
       </p:sp>
       <p:sp>
         <p:nvSpPr>
-          <p:cNvPr id="394" name="Google Shape;394;p14"/>
+          <p:cNvPr id="413" name="Google Shape;413;p14"/>
           <p:cNvSpPr/>
           <p:nvPr/>
         </p:nvSpPr>
@@ -8433,7 +8433,7 @@
       </p:sp>
       <p:sp>
         <p:nvSpPr>
-          <p:cNvPr id="395" name="Google Shape;395;p14"/>
+          <p:cNvPr id="414" name="Google Shape;414;p14"/>
           <p:cNvSpPr/>
           <p:nvPr/>
         </p:nvSpPr>
@@ -8482,7 +8482,7 @@
       </p:sp>
       <p:sp>
         <p:nvSpPr>
-          <p:cNvPr id="396" name="Google Shape;396;p14"/>
+          <p:cNvPr id="415" name="Google Shape;415;p14"/>
           <p:cNvSpPr/>
           <p:nvPr/>
         </p:nvSpPr>
@@ -8545,7 +8545,7 @@
       </p:sp>
       <p:sp>
         <p:nvSpPr>
-          <p:cNvPr id="397" name="Google Shape;397;p14"/>
+          <p:cNvPr id="416" name="Google Shape;416;p14"/>
           <p:cNvSpPr/>
           <p:nvPr/>
         </p:nvSpPr>
@@ -8608,7 +8608,7 @@
       </p:sp>
       <p:sp>
         <p:nvSpPr>
-          <p:cNvPr id="398" name="Google Shape;398;p14"/>
+          <p:cNvPr id="417" name="Google Shape;417;p14"/>
           <p:cNvSpPr/>
           <p:nvPr/>
         </p:nvSpPr>
@@ -8671,7 +8671,7 @@
       </p:sp>
       <p:sp>
         <p:nvSpPr>
-          <p:cNvPr id="399" name="Google Shape;399;p14"/>
+          <p:cNvPr id="418" name="Google Shape;418;p14"/>
           <p:cNvSpPr/>
           <p:nvPr/>
         </p:nvSpPr>
@@ -8734,7 +8734,7 @@
       </p:sp>
       <p:sp>
         <p:nvSpPr>
-          <p:cNvPr id="400" name="Google Shape;400;p14"/>
+          <p:cNvPr id="419" name="Google Shape;419;p14"/>
           <p:cNvSpPr/>
           <p:nvPr/>
         </p:nvSpPr>
@@ -8783,7 +8783,7 @@
       </p:sp>
       <p:sp>
         <p:nvSpPr>
-          <p:cNvPr id="401" name="Google Shape;401;p14"/>
+          <p:cNvPr id="420" name="Google Shape;420;p14"/>
           <p:cNvSpPr/>
           <p:nvPr/>
         </p:nvSpPr>
@@ -8846,7 +8846,7 @@
       </p:sp>
       <p:sp>
         <p:nvSpPr>
-          <p:cNvPr id="402" name="Google Shape;402;p14"/>
+          <p:cNvPr id="421" name="Google Shape;421;p14"/>
           <p:cNvSpPr/>
           <p:nvPr/>
         </p:nvSpPr>
@@ -8909,7 +8909,7 @@
       </p:sp>
       <p:sp>
         <p:nvSpPr>
-          <p:cNvPr id="403" name="Google Shape;403;p14"/>
+          <p:cNvPr id="422" name="Google Shape;422;p14"/>
           <p:cNvSpPr/>
           <p:nvPr/>
         </p:nvSpPr>
@@ -8972,7 +8972,7 @@
       </p:sp>
       <p:sp>
         <p:nvSpPr>
-          <p:cNvPr id="404" name="Google Shape;404;p14"/>
+          <p:cNvPr id="423" name="Google Shape;423;p14"/>
           <p:cNvSpPr/>
           <p:nvPr/>
         </p:nvSpPr>
@@ -9021,7 +9021,7 @@
       </p:sp>
       <p:sp>
         <p:nvSpPr>
-          <p:cNvPr id="405" name="Google Shape;405;p14"/>
+          <p:cNvPr id="424" name="Google Shape;424;p14"/>
           <p:cNvSpPr/>
           <p:nvPr/>
         </p:nvSpPr>
@@ -9084,7 +9084,7 @@
       </p:sp>
       <p:sp>
         <p:nvSpPr>
-          <p:cNvPr id="406" name="Google Shape;406;p14"/>
+          <p:cNvPr id="425" name="Google Shape;425;p14"/>
           <p:cNvSpPr/>
           <p:nvPr/>
         </p:nvSpPr>
@@ -9147,7 +9147,7 @@
       </p:sp>
       <p:sp>
         <p:nvSpPr>
-          <p:cNvPr id="407" name="Google Shape;407;p14"/>
+          <p:cNvPr id="426" name="Google Shape;426;p14"/>
           <p:cNvSpPr/>
           <p:nvPr/>
         </p:nvSpPr>
@@ -9210,7 +9210,7 @@
       </p:sp>
       <p:sp>
         <p:nvSpPr>
-          <p:cNvPr id="408" name="Google Shape;408;p14"/>
+          <p:cNvPr id="427" name="Google Shape;427;p14"/>
           <p:cNvSpPr/>
           <p:nvPr/>
         </p:nvSpPr>
@@ -9259,7 +9259,7 @@
       </p:sp>
       <p:sp>
         <p:nvSpPr>
-          <p:cNvPr id="409" name="Google Shape;409;p14"/>
+          <p:cNvPr id="428" name="Google Shape;428;p14"/>
           <p:cNvSpPr/>
           <p:nvPr/>
         </p:nvSpPr>
@@ -9322,7 +9322,7 @@
       </p:sp>
       <p:sp>
         <p:nvSpPr>
-          <p:cNvPr id="410" name="Google Shape;410;p14"/>
+          <p:cNvPr id="429" name="Google Shape;429;p14"/>
           <p:cNvSpPr/>
           <p:nvPr/>
         </p:nvSpPr>
@@ -9385,7 +9385,7 @@
       </p:sp>
       <p:sp>
         <p:nvSpPr>
-          <p:cNvPr id="411" name="Google Shape;411;p14"/>
+          <p:cNvPr id="430" name="Google Shape;430;p14"/>
           <p:cNvSpPr/>
           <p:nvPr/>
         </p:nvSpPr>
@@ -9448,7 +9448,7 @@
       </p:sp>
       <p:sp>
         <p:nvSpPr>
-          <p:cNvPr id="412" name="Google Shape;412;p14"/>
+          <p:cNvPr id="431" name="Google Shape;431;p14"/>
           <p:cNvSpPr/>
           <p:nvPr/>
         </p:nvSpPr>
@@ -9497,7 +9497,7 @@
       </p:sp>
       <p:sp>
         <p:nvSpPr>
-          <p:cNvPr id="413" name="Google Shape;413;p14"/>
+          <p:cNvPr id="432" name="Google Shape;432;p14"/>
           <p:cNvSpPr/>
           <p:nvPr/>
         </p:nvSpPr>
@@ -9560,7 +9560,7 @@
       </p:sp>
       <p:sp>
         <p:nvSpPr>
-          <p:cNvPr id="414" name="Google Shape;414;p14"/>
+          <p:cNvPr id="433" name="Google Shape;433;p14"/>
           <p:cNvSpPr/>
           <p:nvPr/>
         </p:nvSpPr>
@@ -9623,7 +9623,7 @@
       </p:sp>
       <p:sp>
         <p:nvSpPr>
-          <p:cNvPr id="415" name="Google Shape;415;p14"/>
+          <p:cNvPr id="434" name="Google Shape;434;p14"/>
           <p:cNvSpPr/>
           <p:nvPr/>
         </p:nvSpPr>
@@ -9704,7 +9704,7 @@
     </p:bg>
     <p:spTree>
       <p:nvGrpSpPr>
-        <p:cNvPr id="420" name="Shape 420"/>
+        <p:cNvPr id="439" name="Shape 439"/>
         <p:cNvGrpSpPr/>
         <p:nvPr/>
       </p:nvGrpSpPr>
@@ -9718,14 +9718,14 @@
       </p:grpSpPr>
       <p:sp>
         <p:nvSpPr>
-          <p:cNvPr id="421" name="Google Shape;421;p15"/>
+          <p:cNvPr id="440" name="Google Shape;440;p15"/>
           <p:cNvSpPr/>
           <p:nvPr/>
         </p:nvSpPr>
         <p:spPr>
           <a:xfrm>
             <a:off x="0" y="0"/>
-            <a:ext cx="9144000" cy="50292"/>
+            <a:ext cx="9144000" cy="50400"/>
           </a:xfrm>
           <a:prstGeom prst="rect">
             <a:avLst/>
@@ -9767,14 +9767,14 @@
       </p:sp>
       <p:sp>
         <p:nvSpPr>
-          <p:cNvPr id="422" name="Google Shape;422;p15"/>
+          <p:cNvPr id="441" name="Google Shape;441;p15"/>
           <p:cNvSpPr/>
           <p:nvPr/>
         </p:nvSpPr>
         <p:spPr>
           <a:xfrm>
             <a:off x="411480" y="91440"/>
-            <a:ext cx="4572000" cy="182880"/>
+            <a:ext cx="4572000" cy="183000"/>
           </a:xfrm>
           <a:prstGeom prst="rect">
             <a:avLst/>
@@ -9830,14 +9830,14 @@
       </p:sp>
       <p:sp>
         <p:nvSpPr>
-          <p:cNvPr id="423" name="Google Shape;423;p15"/>
+          <p:cNvPr id="442" name="Google Shape;442;p15"/>
           <p:cNvSpPr/>
           <p:nvPr/>
         </p:nvSpPr>
         <p:spPr>
           <a:xfrm>
             <a:off x="8321040" y="73152"/>
-            <a:ext cx="731520" cy="182880"/>
+            <a:ext cx="731400" cy="183000"/>
           </a:xfrm>
           <a:prstGeom prst="rect">
             <a:avLst/>
@@ -9893,14 +9893,14 @@
       </p:sp>
       <p:sp>
         <p:nvSpPr>
-          <p:cNvPr id="424" name="Google Shape;424;p15"/>
+          <p:cNvPr id="443" name="Google Shape;443;p15"/>
           <p:cNvSpPr/>
           <p:nvPr/>
         </p:nvSpPr>
         <p:spPr>
           <a:xfrm>
             <a:off x="411480" y="310896"/>
-            <a:ext cx="8321040" cy="475488"/>
+            <a:ext cx="8321100" cy="475500"/>
           </a:xfrm>
           <a:prstGeom prst="rect">
             <a:avLst/>
@@ -9993,14 +9993,14 @@
       </p:sp>
       <p:sp>
         <p:nvSpPr>
-          <p:cNvPr id="425" name="Google Shape;425;p15"/>
+          <p:cNvPr id="444" name="Google Shape;444;p15"/>
           <p:cNvSpPr/>
           <p:nvPr/>
         </p:nvSpPr>
         <p:spPr>
           <a:xfrm>
             <a:off x="411480" y="813816"/>
-            <a:ext cx="8321040" cy="16459"/>
+            <a:ext cx="8321100" cy="16500"/>
           </a:xfrm>
           <a:prstGeom prst="rect">
             <a:avLst/>
@@ -10042,14 +10042,14 @@
       </p:sp>
       <p:sp>
         <p:nvSpPr>
-          <p:cNvPr id="426" name="Google Shape;426;p15"/>
+          <p:cNvPr id="445" name="Google Shape;445;p15"/>
           <p:cNvSpPr/>
           <p:nvPr/>
         </p:nvSpPr>
         <p:spPr>
           <a:xfrm>
             <a:off x="411480" y="932688"/>
-            <a:ext cx="5212080" cy="566928"/>
+            <a:ext cx="5212200" cy="567000"/>
           </a:xfrm>
           <a:prstGeom prst="rect">
             <a:avLst/>
@@ -10098,14 +10098,14 @@
       </p:sp>
       <p:sp>
         <p:nvSpPr>
-          <p:cNvPr id="427" name="Google Shape;427;p15"/>
+          <p:cNvPr id="446" name="Google Shape;446;p15"/>
           <p:cNvSpPr/>
           <p:nvPr/>
         </p:nvSpPr>
         <p:spPr>
           <a:xfrm>
             <a:off x="502920" y="932688"/>
-            <a:ext cx="5029200" cy="566928"/>
+            <a:ext cx="5029200" cy="567000"/>
           </a:xfrm>
           <a:prstGeom prst="rect">
             <a:avLst/>
@@ -10159,43 +10159,1070 @@
           </a:p>
         </p:txBody>
       </p:sp>
-      <p:pic>
-        <p:nvPicPr>
-          <p:cNvPr id="428" name="Google Shape;428;p15"/>
-          <p:cNvPicPr preferRelativeResize="0"/>
-          <p:nvPr/>
-        </p:nvPicPr>
-        <p:blipFill rotWithShape="1">
-          <a:blip r:embed="rId3">
-            <a:alphaModFix/>
-          </a:blip>
-          <a:srcRect b="0" l="0" r="0" t="0"/>
-          <a:stretch/>
-        </p:blipFill>
-        <p:spPr>
-          <a:xfrm>
-            <a:off x="411480" y="1572768"/>
-            <a:ext cx="5212080" cy="2880360"/>
-          </a:xfrm>
-          <a:prstGeom prst="rect">
-            <a:avLst/>
-          </a:prstGeom>
-          <a:noFill/>
-          <a:ln>
+      <p:grpSp>
+        <p:nvGrpSpPr>
+          <p:cNvPr id="447" name="Google Shape;447;p15"/>
+          <p:cNvGrpSpPr/>
+          <p:nvPr/>
+        </p:nvGrpSpPr>
+        <p:grpSpPr>
+          <a:xfrm>
+            <a:off x="409575" y="1571625"/>
+            <a:ext cx="5305575" cy="2952750"/>
+            <a:chOff x="409575" y="1571625"/>
+            <a:chExt cx="5305575" cy="2952750"/>
+          </a:xfrm>
+        </p:grpSpPr>
+        <p:sp>
+          <p:nvSpPr>
+            <p:cNvPr id="448" name="Google Shape;448;p15"/>
+            <p:cNvSpPr/>
+            <p:nvPr/>
+          </p:nvSpPr>
+          <p:spPr>
+            <a:xfrm>
+              <a:off x="1714500" y="1571625"/>
+              <a:ext cx="3905400" cy="2857500"/>
+            </a:xfrm>
+            <a:prstGeom prst="rect">
+              <a:avLst/>
+            </a:prstGeom>
+            <a:solidFill>
+              <a:srgbClr val="000000">
+                <a:alpha val="0"/>
+              </a:srgbClr>
+            </a:solidFill>
+            <a:ln>
+              <a:noFill/>
+            </a:ln>
+          </p:spPr>
+          <p:txBody>
+            <a:bodyPr anchorCtr="0" anchor="ctr" bIns="0" lIns="0" spcFirstLastPara="1" rIns="0" wrap="square" tIns="0">
+              <a:noAutofit/>
+            </a:bodyPr>
+            <a:lstStyle/>
+            <a:p>
+              <a:pPr indent="0" lvl="0" marL="0" rtl="0" algn="l">
+                <a:spcBef>
+                  <a:spcPts val="0"/>
+                </a:spcBef>
+                <a:spcAft>
+                  <a:spcPts val="0"/>
+                </a:spcAft>
+                <a:buNone/>
+              </a:pPr>
+              <a:r>
+                <a:t/>
+              </a:r>
+              <a:endParaRPr/>
+            </a:p>
+          </p:txBody>
+        </p:sp>
+        <p:cxnSp>
+          <p:nvCxnSpPr>
+            <p:cNvPr id="449" name="Google Shape;449;p15"/>
+            <p:cNvCxnSpPr/>
+            <p:nvPr/>
+          </p:nvCxnSpPr>
+          <p:spPr>
+            <a:xfrm>
+              <a:off x="1714500" y="1571625"/>
+              <a:ext cx="0" cy="2667000"/>
+            </a:xfrm>
+            <a:prstGeom prst="straightConnector1">
+              <a:avLst/>
+            </a:prstGeom>
+            <a:solidFill>
+              <a:srgbClr val="FFFFFF"/>
+            </a:solidFill>
+            <a:ln cap="flat" cmpd="sng" w="9525">
+              <a:solidFill>
+                <a:srgbClr val="E2E6EA"/>
+              </a:solidFill>
+              <a:prstDash val="solid"/>
+              <a:round/>
+              <a:headEnd len="sm" w="sm" type="none"/>
+              <a:tailEnd len="sm" w="sm" type="none"/>
+            </a:ln>
+          </p:spPr>
+        </p:cxnSp>
+        <p:cxnSp>
+          <p:nvCxnSpPr>
+            <p:cNvPr id="450" name="Google Shape;450;p15"/>
+            <p:cNvCxnSpPr/>
+            <p:nvPr/>
+          </p:nvCxnSpPr>
+          <p:spPr>
+            <a:xfrm>
+              <a:off x="1714500" y="4238625"/>
+              <a:ext cx="3905400" cy="0"/>
+            </a:xfrm>
+            <a:prstGeom prst="straightConnector1">
+              <a:avLst/>
+            </a:prstGeom>
+            <a:solidFill>
+              <a:srgbClr val="FFFFFF"/>
+            </a:solidFill>
+            <a:ln cap="flat" cmpd="sng" w="9525">
+              <a:solidFill>
+                <a:srgbClr val="E2E6EA"/>
+              </a:solidFill>
+              <a:prstDash val="solid"/>
+              <a:round/>
+              <a:headEnd len="sm" w="sm" type="none"/>
+              <a:tailEnd len="sm" w="sm" type="none"/>
+            </a:ln>
+          </p:spPr>
+        </p:cxnSp>
+        <p:grpSp>
+          <p:nvGrpSpPr>
+            <p:cNvPr id="451" name="Google Shape;451;p15"/>
+            <p:cNvGrpSpPr/>
+            <p:nvPr/>
+          </p:nvGrpSpPr>
+          <p:grpSpPr>
+            <a:xfrm>
+              <a:off x="409575" y="1714500"/>
+              <a:ext cx="4876950" cy="333300"/>
+              <a:chOff x="409575" y="1714500"/>
+              <a:chExt cx="4876950" cy="333300"/>
+            </a:xfrm>
+          </p:grpSpPr>
+          <p:sp>
+            <p:nvSpPr>
+              <p:cNvPr id="452" name="Google Shape;452;p15"/>
+              <p:cNvSpPr/>
+              <p:nvPr/>
+            </p:nvSpPr>
+            <p:spPr>
+              <a:xfrm>
+                <a:off x="1714500" y="1714500"/>
+                <a:ext cx="3045600" cy="333300"/>
+              </a:xfrm>
+              <a:prstGeom prst="roundRect">
+                <a:avLst>
+                  <a:gd fmla="val 5714" name="adj"/>
+                </a:avLst>
+              </a:prstGeom>
+              <a:solidFill>
+                <a:srgbClr val="94A3B8"/>
+              </a:solidFill>
+              <a:ln>
+                <a:noFill/>
+              </a:ln>
+            </p:spPr>
+            <p:txBody>
+              <a:bodyPr anchorCtr="0" anchor="ctr" bIns="0" lIns="0" spcFirstLastPara="1" rIns="0" wrap="square" tIns="0">
+                <a:noAutofit/>
+              </a:bodyPr>
+              <a:lstStyle/>
+              <a:p>
+                <a:pPr indent="0" lvl="0" marL="0" rtl="0" algn="l">
+                  <a:spcBef>
+                    <a:spcPts val="0"/>
+                  </a:spcBef>
+                  <a:spcAft>
+                    <a:spcPts val="0"/>
+                  </a:spcAft>
+                  <a:buNone/>
+                </a:pPr>
+                <a:r>
+                  <a:t/>
+                </a:r>
+                <a:endParaRPr/>
+              </a:p>
+            </p:txBody>
+          </p:sp>
+          <p:sp>
+            <p:nvSpPr>
+              <p:cNvPr id="453" name="Google Shape;453;p15"/>
+              <p:cNvSpPr txBox="1"/>
+              <p:nvPr/>
+            </p:nvSpPr>
+            <p:spPr>
+              <a:xfrm>
+                <a:off x="409575" y="1714500"/>
+                <a:ext cx="1257300" cy="333300"/>
+              </a:xfrm>
+              <a:prstGeom prst="rect">
+                <a:avLst/>
+              </a:prstGeom>
+              <a:noFill/>
+              <a:ln>
+                <a:noFill/>
+              </a:ln>
+            </p:spPr>
+            <p:txBody>
+              <a:bodyPr anchorCtr="0" anchor="ctr" bIns="0" lIns="0" spcFirstLastPara="1" rIns="95250" wrap="square" tIns="0">
+                <a:noAutofit/>
+              </a:bodyPr>
+              <a:lstStyle/>
+              <a:p>
+                <a:pPr indent="0" lvl="0" marL="0" rtl="0" algn="r">
+                  <a:spcBef>
+                    <a:spcPts val="0"/>
+                  </a:spcBef>
+                  <a:spcAft>
+                    <a:spcPts val="0"/>
+                  </a:spcAft>
+                  <a:buNone/>
+                </a:pPr>
+                <a:r>
+                  <a:rPr lang="en" sz="1000">
+                    <a:solidFill>
+                      <a:srgbClr val="2D3142"/>
+                    </a:solidFill>
+                    <a:latin typeface="Montserrat"/>
+                    <a:ea typeface="Montserrat"/>
+                    <a:cs typeface="Montserrat"/>
+                    <a:sym typeface="Montserrat"/>
+                  </a:rPr>
+                  <a:t>Train mean</a:t>
+                </a:r>
+                <a:endParaRPr sz="1000">
+                  <a:solidFill>
+                    <a:srgbClr val="2D3142"/>
+                  </a:solidFill>
+                  <a:latin typeface="Montserrat"/>
+                  <a:ea typeface="Montserrat"/>
+                  <a:cs typeface="Montserrat"/>
+                  <a:sym typeface="Montserrat"/>
+                </a:endParaRPr>
+              </a:p>
+            </p:txBody>
+          </p:sp>
+          <p:sp>
+            <p:nvSpPr>
+              <p:cNvPr id="454" name="Google Shape;454;p15"/>
+              <p:cNvSpPr txBox="1"/>
+              <p:nvPr/>
+            </p:nvSpPr>
+            <p:spPr>
+              <a:xfrm>
+                <a:off x="4810125" y="1714500"/>
+                <a:ext cx="476400" cy="333300"/>
+              </a:xfrm>
+              <a:prstGeom prst="rect">
+                <a:avLst/>
+              </a:prstGeom>
+              <a:noFill/>
+              <a:ln>
+                <a:noFill/>
+              </a:ln>
+            </p:spPr>
+            <p:txBody>
+              <a:bodyPr anchorCtr="0" anchor="ctr" bIns="0" lIns="0" spcFirstLastPara="1" rIns="0" wrap="square" tIns="0">
+                <a:noAutofit/>
+              </a:bodyPr>
+              <a:lstStyle/>
+              <a:p>
+                <a:pPr indent="0" lvl="0" marL="0" rtl="0" algn="l">
+                  <a:spcBef>
+                    <a:spcPts val="0"/>
+                  </a:spcBef>
+                  <a:spcAft>
+                    <a:spcPts val="0"/>
+                  </a:spcAft>
+                  <a:buNone/>
+                </a:pPr>
+                <a:r>
+                  <a:rPr b="1" lang="en" sz="1100">
+                    <a:solidFill>
+                      <a:srgbClr val="2D3142"/>
+                    </a:solidFill>
+                    <a:latin typeface="Montserrat"/>
+                    <a:ea typeface="Montserrat"/>
+                    <a:cs typeface="Montserrat"/>
+                    <a:sym typeface="Montserrat"/>
+                  </a:rPr>
+                  <a:t>2.558</a:t>
+                </a:r>
+                <a:endParaRPr b="1" sz="1100">
+                  <a:solidFill>
+                    <a:srgbClr val="2D3142"/>
+                  </a:solidFill>
+                  <a:latin typeface="Montserrat"/>
+                  <a:ea typeface="Montserrat"/>
+                  <a:cs typeface="Montserrat"/>
+                  <a:sym typeface="Montserrat"/>
+                </a:endParaRPr>
+              </a:p>
+            </p:txBody>
+          </p:sp>
+        </p:grpSp>
+        <p:grpSp>
+          <p:nvGrpSpPr>
+            <p:cNvPr id="455" name="Google Shape;455;p15"/>
+            <p:cNvGrpSpPr/>
+            <p:nvPr/>
+          </p:nvGrpSpPr>
+          <p:grpSpPr>
+            <a:xfrm>
+              <a:off x="409575" y="2190750"/>
+              <a:ext cx="5305575" cy="428700"/>
+              <a:chOff x="409575" y="2190750"/>
+              <a:chExt cx="5305575" cy="428700"/>
+            </a:xfrm>
+          </p:grpSpPr>
+          <p:sp>
+            <p:nvSpPr>
+              <p:cNvPr id="456" name="Google Shape;456;p15"/>
+              <p:cNvSpPr/>
+              <p:nvPr/>
+            </p:nvSpPr>
+            <p:spPr>
+              <a:xfrm>
+                <a:off x="1714500" y="2238375"/>
+                <a:ext cx="3480000" cy="333300"/>
+              </a:xfrm>
+              <a:prstGeom prst="roundRect">
+                <a:avLst>
+                  <a:gd fmla="val 5714" name="adj"/>
+                </a:avLst>
+              </a:prstGeom>
+              <a:solidFill>
+                <a:srgbClr val="94A3B8"/>
+              </a:solidFill>
+              <a:ln>
+                <a:noFill/>
+              </a:ln>
+            </p:spPr>
+            <p:txBody>
+              <a:bodyPr anchorCtr="0" anchor="ctr" bIns="0" lIns="0" spcFirstLastPara="1" rIns="0" wrap="square" tIns="0">
+                <a:noAutofit/>
+              </a:bodyPr>
+              <a:lstStyle/>
+              <a:p>
+                <a:pPr indent="0" lvl="0" marL="0" rtl="0" algn="l">
+                  <a:spcBef>
+                    <a:spcPts val="0"/>
+                  </a:spcBef>
+                  <a:spcAft>
+                    <a:spcPts val="0"/>
+                  </a:spcAft>
+                  <a:buNone/>
+                </a:pPr>
+                <a:r>
+                  <a:t/>
+                </a:r>
+                <a:endParaRPr/>
+              </a:p>
+            </p:txBody>
+          </p:sp>
+          <p:sp>
+            <p:nvSpPr>
+              <p:cNvPr id="457" name="Google Shape;457;p15"/>
+              <p:cNvSpPr txBox="1"/>
+              <p:nvPr/>
+            </p:nvSpPr>
+            <p:spPr>
+              <a:xfrm>
+                <a:off x="409575" y="2190750"/>
+                <a:ext cx="1257300" cy="428700"/>
+              </a:xfrm>
+              <a:prstGeom prst="rect">
+                <a:avLst/>
+              </a:prstGeom>
+              <a:noFill/>
+              <a:ln>
+                <a:noFill/>
+              </a:ln>
+            </p:spPr>
+            <p:txBody>
+              <a:bodyPr anchorCtr="0" anchor="ctr" bIns="0" lIns="0" spcFirstLastPara="1" rIns="95250" wrap="square" tIns="0">
+                <a:noAutofit/>
+              </a:bodyPr>
+              <a:lstStyle/>
+              <a:p>
+                <a:pPr indent="0" lvl="0" marL="0" rtl="0" algn="r">
+                  <a:spcBef>
+                    <a:spcPts val="0"/>
+                  </a:spcBef>
+                  <a:spcAft>
+                    <a:spcPts val="0"/>
+                  </a:spcAft>
+                  <a:buNone/>
+                </a:pPr>
+                <a:r>
+                  <a:rPr lang="en" sz="1000">
+                    <a:solidFill>
+                      <a:srgbClr val="2D3142"/>
+                    </a:solidFill>
+                    <a:latin typeface="Montserrat"/>
+                    <a:ea typeface="Montserrat"/>
+                    <a:cs typeface="Montserrat"/>
+                    <a:sym typeface="Montserrat"/>
+                  </a:rPr>
+                  <a:t>Random retrieval (avg 100)</a:t>
+                </a:r>
+                <a:endParaRPr sz="1000">
+                  <a:solidFill>
+                    <a:srgbClr val="2D3142"/>
+                  </a:solidFill>
+                  <a:latin typeface="Montserrat"/>
+                  <a:ea typeface="Montserrat"/>
+                  <a:cs typeface="Montserrat"/>
+                  <a:sym typeface="Montserrat"/>
+                </a:endParaRPr>
+              </a:p>
+            </p:txBody>
+          </p:sp>
+          <p:sp>
+            <p:nvSpPr>
+              <p:cNvPr id="458" name="Google Shape;458;p15"/>
+              <p:cNvSpPr txBox="1"/>
+              <p:nvPr/>
+            </p:nvSpPr>
+            <p:spPr>
+              <a:xfrm>
+                <a:off x="5238750" y="2238375"/>
+                <a:ext cx="476400" cy="333300"/>
+              </a:xfrm>
+              <a:prstGeom prst="rect">
+                <a:avLst/>
+              </a:prstGeom>
+              <a:noFill/>
+              <a:ln>
+                <a:noFill/>
+              </a:ln>
+            </p:spPr>
+            <p:txBody>
+              <a:bodyPr anchorCtr="0" anchor="ctr" bIns="0" lIns="0" spcFirstLastPara="1" rIns="0" wrap="square" tIns="0">
+                <a:noAutofit/>
+              </a:bodyPr>
+              <a:lstStyle/>
+              <a:p>
+                <a:pPr indent="0" lvl="0" marL="0" rtl="0" algn="l">
+                  <a:spcBef>
+                    <a:spcPts val="0"/>
+                  </a:spcBef>
+                  <a:spcAft>
+                    <a:spcPts val="0"/>
+                  </a:spcAft>
+                  <a:buNone/>
+                </a:pPr>
+                <a:r>
+                  <a:rPr b="1" lang="en" sz="1100">
+                    <a:solidFill>
+                      <a:srgbClr val="2D3142"/>
+                    </a:solidFill>
+                    <a:latin typeface="Montserrat"/>
+                    <a:ea typeface="Montserrat"/>
+                    <a:cs typeface="Montserrat"/>
+                    <a:sym typeface="Montserrat"/>
+                  </a:rPr>
+                  <a:t>2.923</a:t>
+                </a:r>
+                <a:endParaRPr b="1" sz="1100">
+                  <a:solidFill>
+                    <a:srgbClr val="2D3142"/>
+                  </a:solidFill>
+                  <a:latin typeface="Montserrat"/>
+                  <a:ea typeface="Montserrat"/>
+                  <a:cs typeface="Montserrat"/>
+                  <a:sym typeface="Montserrat"/>
+                </a:endParaRPr>
+              </a:p>
+            </p:txBody>
+          </p:sp>
+        </p:grpSp>
+        <p:grpSp>
+          <p:nvGrpSpPr>
+            <p:cNvPr id="459" name="Google Shape;459;p15"/>
+            <p:cNvGrpSpPr/>
+            <p:nvPr/>
+          </p:nvGrpSpPr>
+          <p:grpSpPr>
+            <a:xfrm>
+              <a:off x="409575" y="2762250"/>
+              <a:ext cx="4638825" cy="333300"/>
+              <a:chOff x="409575" y="2762250"/>
+              <a:chExt cx="4638825" cy="333300"/>
+            </a:xfrm>
+          </p:grpSpPr>
+          <p:sp>
+            <p:nvSpPr>
+              <p:cNvPr id="460" name="Google Shape;460;p15"/>
+              <p:cNvSpPr/>
+              <p:nvPr/>
+            </p:nvSpPr>
+            <p:spPr>
+              <a:xfrm>
+                <a:off x="1714500" y="2762250"/>
+                <a:ext cx="2807400" cy="333300"/>
+              </a:xfrm>
+              <a:prstGeom prst="roundRect">
+                <a:avLst>
+                  <a:gd fmla="val 5714" name="adj"/>
+                </a:avLst>
+              </a:prstGeom>
+              <a:solidFill>
+                <a:srgbClr val="94A3B8"/>
+              </a:solidFill>
+              <a:ln>
+                <a:noFill/>
+              </a:ln>
+            </p:spPr>
+            <p:txBody>
+              <a:bodyPr anchorCtr="0" anchor="ctr" bIns="0" lIns="0" spcFirstLastPara="1" rIns="0" wrap="square" tIns="0">
+                <a:noAutofit/>
+              </a:bodyPr>
+              <a:lstStyle/>
+              <a:p>
+                <a:pPr indent="0" lvl="0" marL="0" rtl="0" algn="l">
+                  <a:spcBef>
+                    <a:spcPts val="0"/>
+                  </a:spcBef>
+                  <a:spcAft>
+                    <a:spcPts val="0"/>
+                  </a:spcAft>
+                  <a:buNone/>
+                </a:pPr>
+                <a:r>
+                  <a:t/>
+                </a:r>
+                <a:endParaRPr/>
+              </a:p>
+            </p:txBody>
+          </p:sp>
+          <p:sp>
+            <p:nvSpPr>
+              <p:cNvPr id="461" name="Google Shape;461;p15"/>
+              <p:cNvSpPr txBox="1"/>
+              <p:nvPr/>
+            </p:nvSpPr>
+            <p:spPr>
+              <a:xfrm>
+                <a:off x="409575" y="2762250"/>
+                <a:ext cx="1257300" cy="333300"/>
+              </a:xfrm>
+              <a:prstGeom prst="rect">
+                <a:avLst/>
+              </a:prstGeom>
+              <a:noFill/>
+              <a:ln>
+                <a:noFill/>
+              </a:ln>
+            </p:spPr>
+            <p:txBody>
+              <a:bodyPr anchorCtr="0" anchor="ctr" bIns="0" lIns="0" spcFirstLastPara="1" rIns="95250" wrap="square" tIns="0">
+                <a:noAutofit/>
+              </a:bodyPr>
+              <a:lstStyle/>
+              <a:p>
+                <a:pPr indent="0" lvl="0" marL="0" rtl="0" algn="r">
+                  <a:spcBef>
+                    <a:spcPts val="0"/>
+                  </a:spcBef>
+                  <a:spcAft>
+                    <a:spcPts val="0"/>
+                  </a:spcAft>
+                  <a:buNone/>
+                </a:pPr>
+                <a:r>
+                  <a:rPr lang="en" sz="1000">
+                    <a:solidFill>
+                      <a:srgbClr val="2D3142"/>
+                    </a:solidFill>
+                    <a:latin typeface="Montserrat"/>
+                    <a:ea typeface="Montserrat"/>
+                    <a:cs typeface="Montserrat"/>
+                    <a:sym typeface="Montserrat"/>
+                  </a:rPr>
+                  <a:t>Previous-year value</a:t>
+                </a:r>
+                <a:endParaRPr sz="1000">
+                  <a:solidFill>
+                    <a:srgbClr val="2D3142"/>
+                  </a:solidFill>
+                  <a:latin typeface="Montserrat"/>
+                  <a:ea typeface="Montserrat"/>
+                  <a:cs typeface="Montserrat"/>
+                  <a:sym typeface="Montserrat"/>
+                </a:endParaRPr>
+              </a:p>
+            </p:txBody>
+          </p:sp>
+          <p:sp>
+            <p:nvSpPr>
+              <p:cNvPr id="462" name="Google Shape;462;p15"/>
+              <p:cNvSpPr txBox="1"/>
+              <p:nvPr/>
+            </p:nvSpPr>
+            <p:spPr>
+              <a:xfrm>
+                <a:off x="4572000" y="2762250"/>
+                <a:ext cx="476400" cy="333300"/>
+              </a:xfrm>
+              <a:prstGeom prst="rect">
+                <a:avLst/>
+              </a:prstGeom>
+              <a:noFill/>
+              <a:ln>
+                <a:noFill/>
+              </a:ln>
+            </p:spPr>
+            <p:txBody>
+              <a:bodyPr anchorCtr="0" anchor="ctr" bIns="0" lIns="0" spcFirstLastPara="1" rIns="0" wrap="square" tIns="0">
+                <a:noAutofit/>
+              </a:bodyPr>
+              <a:lstStyle/>
+              <a:p>
+                <a:pPr indent="0" lvl="0" marL="0" rtl="0" algn="l">
+                  <a:spcBef>
+                    <a:spcPts val="0"/>
+                  </a:spcBef>
+                  <a:spcAft>
+                    <a:spcPts val="0"/>
+                  </a:spcAft>
+                  <a:buNone/>
+                </a:pPr>
+                <a:r>
+                  <a:rPr b="1" lang="en" sz="1100">
+                    <a:solidFill>
+                      <a:srgbClr val="2D3142"/>
+                    </a:solidFill>
+                    <a:latin typeface="Montserrat"/>
+                    <a:ea typeface="Montserrat"/>
+                    <a:cs typeface="Montserrat"/>
+                    <a:sym typeface="Montserrat"/>
+                  </a:rPr>
+                  <a:t>2.358</a:t>
+                </a:r>
+                <a:endParaRPr b="1" sz="1100">
+                  <a:solidFill>
+                    <a:srgbClr val="2D3142"/>
+                  </a:solidFill>
+                  <a:latin typeface="Montserrat"/>
+                  <a:ea typeface="Montserrat"/>
+                  <a:cs typeface="Montserrat"/>
+                  <a:sym typeface="Montserrat"/>
+                </a:endParaRPr>
+              </a:p>
+            </p:txBody>
+          </p:sp>
+        </p:grpSp>
+        <p:grpSp>
+          <p:nvGrpSpPr>
+            <p:cNvPr id="463" name="Google Shape;463;p15"/>
+            <p:cNvGrpSpPr/>
+            <p:nvPr/>
+          </p:nvGrpSpPr>
+          <p:grpSpPr>
+            <a:xfrm>
+              <a:off x="409575" y="3286125"/>
+              <a:ext cx="4810275" cy="333300"/>
+              <a:chOff x="409575" y="3286125"/>
+              <a:chExt cx="4810275" cy="333300"/>
+            </a:xfrm>
+          </p:grpSpPr>
+          <p:sp>
+            <p:nvSpPr>
+              <p:cNvPr id="464" name="Google Shape;464;p15"/>
+              <p:cNvSpPr/>
+              <p:nvPr/>
+            </p:nvSpPr>
+            <p:spPr>
+              <a:xfrm>
+                <a:off x="1714500" y="3286125"/>
+                <a:ext cx="2981400" cy="333300"/>
+              </a:xfrm>
+              <a:prstGeom prst="roundRect">
+                <a:avLst>
+                  <a:gd fmla="val 5714" name="adj"/>
+                </a:avLst>
+              </a:prstGeom>
+              <a:solidFill>
+                <a:srgbClr val="94A3B8"/>
+              </a:solidFill>
+              <a:ln>
+                <a:noFill/>
+              </a:ln>
+            </p:spPr>
+            <p:txBody>
+              <a:bodyPr anchorCtr="0" anchor="ctr" bIns="0" lIns="0" spcFirstLastPara="1" rIns="0" wrap="square" tIns="0">
+                <a:noAutofit/>
+              </a:bodyPr>
+              <a:lstStyle/>
+              <a:p>
+                <a:pPr indent="0" lvl="0" marL="0" rtl="0" algn="l">
+                  <a:spcBef>
+                    <a:spcPts val="0"/>
+                  </a:spcBef>
+                  <a:spcAft>
+                    <a:spcPts val="0"/>
+                  </a:spcAft>
+                  <a:buNone/>
+                </a:pPr>
+                <a:r>
+                  <a:t/>
+                </a:r>
+                <a:endParaRPr/>
+              </a:p>
+            </p:txBody>
+          </p:sp>
+          <p:sp>
+            <p:nvSpPr>
+              <p:cNvPr id="465" name="Google Shape;465;p15"/>
+              <p:cNvSpPr txBox="1"/>
+              <p:nvPr/>
+            </p:nvSpPr>
+            <p:spPr>
+              <a:xfrm>
+                <a:off x="409575" y="3286125"/>
+                <a:ext cx="1257300" cy="333300"/>
+              </a:xfrm>
+              <a:prstGeom prst="rect">
+                <a:avLst/>
+              </a:prstGeom>
+              <a:noFill/>
+              <a:ln>
+                <a:noFill/>
+              </a:ln>
+            </p:spPr>
+            <p:txBody>
+              <a:bodyPr anchorCtr="0" anchor="ctr" bIns="0" lIns="0" spcFirstLastPara="1" rIns="95250" wrap="square" tIns="0">
+                <a:noAutofit/>
+              </a:bodyPr>
+              <a:lstStyle/>
+              <a:p>
+                <a:pPr indent="0" lvl="0" marL="0" rtl="0" algn="r">
+                  <a:spcBef>
+                    <a:spcPts val="0"/>
+                  </a:spcBef>
+                  <a:spcAft>
+                    <a:spcPts val="0"/>
+                  </a:spcAft>
+                  <a:buNone/>
+                </a:pPr>
+                <a:r>
+                  <a:rPr lang="en" sz="1000">
+                    <a:solidFill>
+                      <a:srgbClr val="2D3142"/>
+                    </a:solidFill>
+                    <a:latin typeface="Montserrat"/>
+                    <a:ea typeface="Montserrat"/>
+                    <a:cs typeface="Montserrat"/>
+                    <a:sym typeface="Montserrat"/>
+                  </a:rPr>
+                  <a:t>Cosine k=5</a:t>
+                </a:r>
+                <a:endParaRPr sz="1000">
+                  <a:solidFill>
+                    <a:srgbClr val="2D3142"/>
+                  </a:solidFill>
+                  <a:latin typeface="Montserrat"/>
+                  <a:ea typeface="Montserrat"/>
+                  <a:cs typeface="Montserrat"/>
+                  <a:sym typeface="Montserrat"/>
+                </a:endParaRPr>
+              </a:p>
+            </p:txBody>
+          </p:sp>
+          <p:sp>
+            <p:nvSpPr>
+              <p:cNvPr id="466" name="Google Shape;466;p15"/>
+              <p:cNvSpPr txBox="1"/>
+              <p:nvPr/>
+            </p:nvSpPr>
+            <p:spPr>
+              <a:xfrm>
+                <a:off x="4743450" y="3286125"/>
+                <a:ext cx="476400" cy="333300"/>
+              </a:xfrm>
+              <a:prstGeom prst="rect">
+                <a:avLst/>
+              </a:prstGeom>
+              <a:noFill/>
+              <a:ln>
+                <a:noFill/>
+              </a:ln>
+            </p:spPr>
+            <p:txBody>
+              <a:bodyPr anchorCtr="0" anchor="ctr" bIns="0" lIns="0" spcFirstLastPara="1" rIns="0" wrap="square" tIns="0">
+                <a:noAutofit/>
+              </a:bodyPr>
+              <a:lstStyle/>
+              <a:p>
+                <a:pPr indent="0" lvl="0" marL="0" rtl="0" algn="l">
+                  <a:spcBef>
+                    <a:spcPts val="0"/>
+                  </a:spcBef>
+                  <a:spcAft>
+                    <a:spcPts val="0"/>
+                  </a:spcAft>
+                  <a:buNone/>
+                </a:pPr>
+                <a:r>
+                  <a:rPr b="1" lang="en" sz="1100">
+                    <a:solidFill>
+                      <a:srgbClr val="2D3142"/>
+                    </a:solidFill>
+                    <a:latin typeface="Montserrat"/>
+                    <a:ea typeface="Montserrat"/>
+                    <a:cs typeface="Montserrat"/>
+                    <a:sym typeface="Montserrat"/>
+                  </a:rPr>
+                  <a:t>2.504</a:t>
+                </a:r>
+                <a:endParaRPr b="1" sz="1100">
+                  <a:solidFill>
+                    <a:srgbClr val="2D3142"/>
+                  </a:solidFill>
+                  <a:latin typeface="Montserrat"/>
+                  <a:ea typeface="Montserrat"/>
+                  <a:cs typeface="Montserrat"/>
+                  <a:sym typeface="Montserrat"/>
+                </a:endParaRPr>
+              </a:p>
+            </p:txBody>
+          </p:sp>
+        </p:grpSp>
+        <p:grpSp>
+          <p:nvGrpSpPr>
+            <p:cNvPr id="467" name="Google Shape;467;p15"/>
+            <p:cNvGrpSpPr/>
+            <p:nvPr/>
+          </p:nvGrpSpPr>
+          <p:grpSpPr>
+            <a:xfrm>
+              <a:off x="409575" y="3762375"/>
+              <a:ext cx="4734075" cy="428700"/>
+              <a:chOff x="409575" y="3762375"/>
+              <a:chExt cx="4734075" cy="428700"/>
+            </a:xfrm>
+          </p:grpSpPr>
+          <p:sp>
+            <p:nvSpPr>
+              <p:cNvPr id="468" name="Google Shape;468;p15"/>
+              <p:cNvSpPr/>
+              <p:nvPr/>
+            </p:nvSpPr>
+            <p:spPr>
+              <a:xfrm>
+                <a:off x="1714500" y="3810000"/>
+                <a:ext cx="2899200" cy="333300"/>
+              </a:xfrm>
+              <a:prstGeom prst="roundRect">
+                <a:avLst>
+                  <a:gd fmla="val 5714" name="adj"/>
+                </a:avLst>
+              </a:prstGeom>
+              <a:solidFill>
+                <a:srgbClr val="017EFF"/>
+              </a:solidFill>
+              <a:ln>
+                <a:noFill/>
+              </a:ln>
+            </p:spPr>
+            <p:txBody>
+              <a:bodyPr anchorCtr="0" anchor="ctr" bIns="0" lIns="0" spcFirstLastPara="1" rIns="0" wrap="square" tIns="0">
+                <a:noAutofit/>
+              </a:bodyPr>
+              <a:lstStyle/>
+              <a:p>
+                <a:pPr indent="0" lvl="0" marL="0" rtl="0" algn="l">
+                  <a:spcBef>
+                    <a:spcPts val="0"/>
+                  </a:spcBef>
+                  <a:spcAft>
+                    <a:spcPts val="0"/>
+                  </a:spcAft>
+                  <a:buNone/>
+                </a:pPr>
+                <a:r>
+                  <a:t/>
+                </a:r>
+                <a:endParaRPr/>
+              </a:p>
+            </p:txBody>
+          </p:sp>
+          <p:sp>
+            <p:nvSpPr>
+              <p:cNvPr id="469" name="Google Shape;469;p15"/>
+              <p:cNvSpPr txBox="1"/>
+              <p:nvPr/>
+            </p:nvSpPr>
+            <p:spPr>
+              <a:xfrm>
+                <a:off x="409575" y="3762375"/>
+                <a:ext cx="1257300" cy="428700"/>
+              </a:xfrm>
+              <a:prstGeom prst="rect">
+                <a:avLst/>
+              </a:prstGeom>
+              <a:noFill/>
+              <a:ln>
+                <a:noFill/>
+              </a:ln>
+            </p:spPr>
+            <p:txBody>
+              <a:bodyPr anchorCtr="0" anchor="ctr" bIns="0" lIns="0" spcFirstLastPara="1" rIns="95250" wrap="square" tIns="0">
+                <a:noAutofit/>
+              </a:bodyPr>
+              <a:lstStyle/>
+              <a:p>
+                <a:pPr indent="0" lvl="0" marL="0" rtl="0" algn="r">
+                  <a:spcBef>
+                    <a:spcPts val="0"/>
+                  </a:spcBef>
+                  <a:spcAft>
+                    <a:spcPts val="0"/>
+                  </a:spcAft>
+                  <a:buNone/>
+                </a:pPr>
+                <a:r>
+                  <a:rPr b="1" lang="en" sz="1000">
+                    <a:solidFill>
+                      <a:srgbClr val="022369"/>
+                    </a:solidFill>
+                    <a:latin typeface="Montserrat"/>
+                    <a:ea typeface="Montserrat"/>
+                    <a:cs typeface="Montserrat"/>
+                    <a:sym typeface="Montserrat"/>
+                  </a:rPr>
+                  <a:t>Scaled Euclidean k=8 (selected)</a:t>
+                </a:r>
+                <a:endParaRPr b="1" sz="1000">
+                  <a:solidFill>
+                    <a:srgbClr val="022369"/>
+                  </a:solidFill>
+                  <a:latin typeface="Montserrat"/>
+                  <a:ea typeface="Montserrat"/>
+                  <a:cs typeface="Montserrat"/>
+                  <a:sym typeface="Montserrat"/>
+                </a:endParaRPr>
+              </a:p>
+            </p:txBody>
+          </p:sp>
+          <p:sp>
+            <p:nvSpPr>
+              <p:cNvPr id="470" name="Google Shape;470;p15"/>
+              <p:cNvSpPr txBox="1"/>
+              <p:nvPr/>
+            </p:nvSpPr>
+            <p:spPr>
+              <a:xfrm>
+                <a:off x="4667250" y="3810000"/>
+                <a:ext cx="476400" cy="333300"/>
+              </a:xfrm>
+              <a:prstGeom prst="rect">
+                <a:avLst/>
+              </a:prstGeom>
+              <a:noFill/>
+              <a:ln>
+                <a:noFill/>
+              </a:ln>
+            </p:spPr>
+            <p:txBody>
+              <a:bodyPr anchorCtr="0" anchor="ctr" bIns="0" lIns="0" spcFirstLastPara="1" rIns="0" wrap="square" tIns="0">
+                <a:noAutofit/>
+              </a:bodyPr>
+              <a:lstStyle/>
+              <a:p>
+                <a:pPr indent="0" lvl="0" marL="0" rtl="0" algn="l">
+                  <a:spcBef>
+                    <a:spcPts val="0"/>
+                  </a:spcBef>
+                  <a:spcAft>
+                    <a:spcPts val="0"/>
+                  </a:spcAft>
+                  <a:buNone/>
+                </a:pPr>
+                <a:r>
+                  <a:rPr b="1" lang="en" sz="1100">
+                    <a:solidFill>
+                      <a:srgbClr val="022369"/>
+                    </a:solidFill>
+                    <a:latin typeface="Montserrat"/>
+                    <a:ea typeface="Montserrat"/>
+                    <a:cs typeface="Montserrat"/>
+                    <a:sym typeface="Montserrat"/>
+                  </a:rPr>
+                  <a:t>2.435</a:t>
+                </a:r>
+                <a:endParaRPr b="1" sz="1100">
+                  <a:solidFill>
+                    <a:srgbClr val="022369"/>
+                  </a:solidFill>
+                  <a:latin typeface="Montserrat"/>
+                  <a:ea typeface="Montserrat"/>
+                  <a:cs typeface="Montserrat"/>
+                  <a:sym typeface="Montserrat"/>
+                </a:endParaRPr>
+              </a:p>
+            </p:txBody>
+          </p:sp>
+        </p:grpSp>
+        <p:sp>
+          <p:nvSpPr>
+            <p:cNvPr id="471" name="Google Shape;471;p15"/>
+            <p:cNvSpPr txBox="1"/>
+            <p:nvPr/>
+          </p:nvSpPr>
+          <p:spPr>
+            <a:xfrm>
+              <a:off x="1714500" y="4333875"/>
+              <a:ext cx="3905400" cy="190500"/>
+            </a:xfrm>
+            <a:prstGeom prst="rect">
+              <a:avLst/>
+            </a:prstGeom>
             <a:noFill/>
-          </a:ln>
-        </p:spPr>
-      </p:pic>
-      <p:sp>
-        <p:nvSpPr>
-          <p:cNvPr id="429" name="Google Shape;429;p15"/>
-          <p:cNvSpPr/>
-          <p:nvPr/>
-        </p:nvSpPr>
-        <p:spPr>
-          <a:xfrm>
-            <a:off x="411480" y="4471416"/>
-            <a:ext cx="5212080" cy="237744"/>
+            <a:ln>
+              <a:noFill/>
+            </a:ln>
+          </p:spPr>
+          <p:txBody>
+            <a:bodyPr anchorCtr="0" anchor="ctr" bIns="0" lIns="0" spcFirstLastPara="1" rIns="0" wrap="square" tIns="0">
+              <a:noAutofit/>
+            </a:bodyPr>
+            <a:lstStyle/>
+            <a:p>
+              <a:pPr indent="0" lvl="0" marL="0" rtl="0" algn="ctr">
+                <a:spcBef>
+                  <a:spcPts val="0"/>
+                </a:spcBef>
+                <a:spcAft>
+                  <a:spcPts val="0"/>
+                </a:spcAft>
+                <a:buNone/>
+              </a:pPr>
+              <a:r>
+                <a:rPr lang="en" sz="900">
+                  <a:solidFill>
+                    <a:srgbClr val="6B7280"/>
+                  </a:solidFill>
+                  <a:latin typeface="Montserrat"/>
+                  <a:ea typeface="Montserrat"/>
+                  <a:cs typeface="Montserrat"/>
+                  <a:sym typeface="Montserrat"/>
+                </a:rPr>
+                <a:t>2021-2023 test MAE on GDP growth</a:t>
+              </a:r>
+              <a:endParaRPr sz="900">
+                <a:solidFill>
+                  <a:srgbClr val="6B7280"/>
+                </a:solidFill>
+                <a:latin typeface="Montserrat"/>
+                <a:ea typeface="Montserrat"/>
+                <a:cs typeface="Montserrat"/>
+                <a:sym typeface="Montserrat"/>
+              </a:endParaRPr>
+            </a:p>
+          </p:txBody>
+        </p:sp>
+      </p:grpSp>
+      <p:sp>
+        <p:nvSpPr>
+          <p:cNvPr id="472" name="Google Shape;472;p15"/>
+          <p:cNvSpPr/>
+          <p:nvPr/>
+        </p:nvSpPr>
+        <p:spPr>
+          <a:xfrm>
+            <a:off x="411480" y="4565105"/>
+            <a:ext cx="5212200" cy="237600"/>
           </a:xfrm>
           <a:prstGeom prst="rect">
             <a:avLst/>
@@ -10251,14 +11278,14 @@
       </p:sp>
       <p:sp>
         <p:nvSpPr>
-          <p:cNvPr id="430" name="Google Shape;430;p15"/>
+          <p:cNvPr id="473" name="Google Shape;473;p15"/>
           <p:cNvSpPr/>
           <p:nvPr/>
         </p:nvSpPr>
         <p:spPr>
           <a:xfrm>
             <a:off x="5806440" y="932688"/>
-            <a:ext cx="2926080" cy="960120"/>
+            <a:ext cx="2926200" cy="960000"/>
           </a:xfrm>
           <a:prstGeom prst="rect">
             <a:avLst/>
@@ -10307,14 +11334,14 @@
       </p:sp>
       <p:sp>
         <p:nvSpPr>
-          <p:cNvPr id="431" name="Google Shape;431;p15"/>
+          <p:cNvPr id="474" name="Google Shape;474;p15"/>
           <p:cNvSpPr/>
           <p:nvPr/>
         </p:nvSpPr>
         <p:spPr>
           <a:xfrm>
             <a:off x="5806440" y="960120"/>
-            <a:ext cx="2926080" cy="475488"/>
+            <a:ext cx="2926200" cy="475500"/>
           </a:xfrm>
           <a:prstGeom prst="rect">
             <a:avLst/>
@@ -10370,14 +11397,14 @@
       </p:sp>
       <p:sp>
         <p:nvSpPr>
-          <p:cNvPr id="432" name="Google Shape;432;p15"/>
+          <p:cNvPr id="475" name="Google Shape;475;p15"/>
           <p:cNvSpPr/>
           <p:nvPr/>
         </p:nvSpPr>
         <p:spPr>
           <a:xfrm>
             <a:off x="5806440" y="1417320"/>
-            <a:ext cx="2926080" cy="256032"/>
+            <a:ext cx="2926200" cy="255900"/>
           </a:xfrm>
           <a:prstGeom prst="rect">
             <a:avLst/>
@@ -10433,14 +11460,14 @@
       </p:sp>
       <p:sp>
         <p:nvSpPr>
-          <p:cNvPr id="433" name="Google Shape;433;p15"/>
+          <p:cNvPr id="476" name="Google Shape;476;p15"/>
           <p:cNvSpPr/>
           <p:nvPr/>
         </p:nvSpPr>
         <p:spPr>
           <a:xfrm>
             <a:off x="5806440" y="1975104"/>
-            <a:ext cx="2926080" cy="896112"/>
+            <a:ext cx="2926200" cy="896100"/>
           </a:xfrm>
           <a:prstGeom prst="rect">
             <a:avLst/>
@@ -10482,14 +11509,14 @@
       </p:sp>
       <p:sp>
         <p:nvSpPr>
-          <p:cNvPr id="434" name="Google Shape;434;p15"/>
+          <p:cNvPr id="477" name="Google Shape;477;p15"/>
           <p:cNvSpPr/>
           <p:nvPr/>
         </p:nvSpPr>
         <p:spPr>
           <a:xfrm>
             <a:off x="5806440" y="1975104"/>
-            <a:ext cx="50292" cy="868680"/>
+            <a:ext cx="50400" cy="868800"/>
           </a:xfrm>
           <a:prstGeom prst="rect">
             <a:avLst/>
@@ -10531,14 +11558,14 @@
       </p:sp>
       <p:sp>
         <p:nvSpPr>
-          <p:cNvPr id="435" name="Google Shape;435;p15"/>
+          <p:cNvPr id="478" name="Google Shape;478;p15"/>
           <p:cNvSpPr/>
           <p:nvPr/>
         </p:nvSpPr>
         <p:spPr>
           <a:xfrm>
             <a:off x="5897880" y="2011680"/>
-            <a:ext cx="2779776" cy="347472"/>
+            <a:ext cx="2779800" cy="347400"/>
           </a:xfrm>
           <a:prstGeom prst="rect">
             <a:avLst/>
@@ -10631,14 +11658,14 @@
       </p:sp>
       <p:sp>
         <p:nvSpPr>
-          <p:cNvPr id="436" name="Google Shape;436;p15"/>
+          <p:cNvPr id="479" name="Google Shape;479;p15"/>
           <p:cNvSpPr/>
           <p:nvPr/>
         </p:nvSpPr>
         <p:spPr>
           <a:xfrm>
             <a:off x="5897880" y="2377440"/>
-            <a:ext cx="2779776" cy="457200"/>
+            <a:ext cx="2779800" cy="457200"/>
           </a:xfrm>
           <a:prstGeom prst="rect">
             <a:avLst/>
@@ -10694,14 +11721,14 @@
       </p:sp>
       <p:sp>
         <p:nvSpPr>
-          <p:cNvPr id="437" name="Google Shape;437;p15"/>
+          <p:cNvPr id="480" name="Google Shape;480;p15"/>
           <p:cNvSpPr/>
           <p:nvPr/>
         </p:nvSpPr>
         <p:spPr>
           <a:xfrm>
             <a:off x="5806440" y="2944368"/>
-            <a:ext cx="2926080" cy="896112"/>
+            <a:ext cx="2926200" cy="896100"/>
           </a:xfrm>
           <a:prstGeom prst="rect">
             <a:avLst/>
@@ -10743,14 +11770,14 @@
       </p:sp>
       <p:sp>
         <p:nvSpPr>
-          <p:cNvPr id="438" name="Google Shape;438;p15"/>
+          <p:cNvPr id="481" name="Google Shape;481;p15"/>
           <p:cNvSpPr/>
           <p:nvPr/>
         </p:nvSpPr>
         <p:spPr>
           <a:xfrm>
             <a:off x="5806440" y="2944368"/>
-            <a:ext cx="50292" cy="868680"/>
+            <a:ext cx="50400" cy="868800"/>
           </a:xfrm>
           <a:prstGeom prst="rect">
             <a:avLst/>
@@ -10792,14 +11819,14 @@
       </p:sp>
       <p:sp>
         <p:nvSpPr>
-          <p:cNvPr id="439" name="Google Shape;439;p15"/>
+          <p:cNvPr id="482" name="Google Shape;482;p15"/>
           <p:cNvSpPr/>
           <p:nvPr/>
         </p:nvSpPr>
         <p:spPr>
           <a:xfrm>
             <a:off x="5897880" y="2980944"/>
-            <a:ext cx="2779776" cy="347472"/>
+            <a:ext cx="2779800" cy="347400"/>
           </a:xfrm>
           <a:prstGeom prst="rect">
             <a:avLst/>
@@ -10892,14 +11919,14 @@
       </p:sp>
       <p:sp>
         <p:nvSpPr>
-          <p:cNvPr id="440" name="Google Shape;440;p15"/>
+          <p:cNvPr id="483" name="Google Shape;483;p15"/>
           <p:cNvSpPr/>
           <p:nvPr/>
         </p:nvSpPr>
         <p:spPr>
           <a:xfrm>
             <a:off x="5897880" y="3346704"/>
-            <a:ext cx="2779776" cy="457200"/>
+            <a:ext cx="2779800" cy="457200"/>
           </a:xfrm>
           <a:prstGeom prst="rect">
             <a:avLst/>
@@ -10955,14 +11982,14 @@
       </p:sp>
       <p:sp>
         <p:nvSpPr>
-          <p:cNvPr id="441" name="Google Shape;441;p15"/>
+          <p:cNvPr id="484" name="Google Shape;484;p15"/>
           <p:cNvSpPr/>
           <p:nvPr/>
         </p:nvSpPr>
         <p:spPr>
           <a:xfrm>
             <a:off x="5806440" y="3913632"/>
-            <a:ext cx="2926080" cy="896112"/>
+            <a:ext cx="2926200" cy="896100"/>
           </a:xfrm>
           <a:prstGeom prst="rect">
             <a:avLst/>
@@ -11004,14 +12031,14 @@
       </p:sp>
       <p:sp>
         <p:nvSpPr>
-          <p:cNvPr id="442" name="Google Shape;442;p15"/>
+          <p:cNvPr id="485" name="Google Shape;485;p15"/>
           <p:cNvSpPr/>
           <p:nvPr/>
         </p:nvSpPr>
         <p:spPr>
           <a:xfrm>
             <a:off x="5806440" y="3913632"/>
-            <a:ext cx="50292" cy="868680"/>
+            <a:ext cx="50400" cy="868800"/>
           </a:xfrm>
           <a:prstGeom prst="rect">
             <a:avLst/>
@@ -11053,14 +12080,14 @@
       </p:sp>
       <p:sp>
         <p:nvSpPr>
-          <p:cNvPr id="443" name="Google Shape;443;p15"/>
+          <p:cNvPr id="486" name="Google Shape;486;p15"/>
           <p:cNvSpPr/>
           <p:nvPr/>
         </p:nvSpPr>
         <p:spPr>
           <a:xfrm>
             <a:off x="5897880" y="3950208"/>
-            <a:ext cx="2779776" cy="347472"/>
+            <a:ext cx="2779800" cy="347400"/>
           </a:xfrm>
           <a:prstGeom prst="rect">
             <a:avLst/>
@@ -11153,14 +12180,14 @@
       </p:sp>
       <p:sp>
         <p:nvSpPr>
-          <p:cNvPr id="444" name="Google Shape;444;p15"/>
+          <p:cNvPr id="487" name="Google Shape;487;p15"/>
           <p:cNvSpPr/>
           <p:nvPr/>
         </p:nvSpPr>
         <p:spPr>
           <a:xfrm>
             <a:off x="5897880" y="4315968"/>
-            <a:ext cx="2779776" cy="457200"/>
+            <a:ext cx="2779800" cy="457200"/>
           </a:xfrm>
           <a:prstGeom prst="rect">
             <a:avLst/>
@@ -11216,7 +12243,7 @@
       </p:sp>
       <p:sp>
         <p:nvSpPr>
-          <p:cNvPr id="445" name="Google Shape;445;p15"/>
+          <p:cNvPr id="488" name="Google Shape;488;p15"/>
           <p:cNvSpPr txBox="1"/>
           <p:nvPr/>
         </p:nvSpPr>
@@ -11275,7 +12302,7 @@
     </p:bg>
     <p:spTree>
       <p:nvGrpSpPr>
-        <p:cNvPr id="450" name="Shape 450"/>
+        <p:cNvPr id="493" name="Shape 493"/>
         <p:cNvGrpSpPr/>
         <p:nvPr/>
       </p:nvGrpSpPr>
@@ -11289,7 +12316,7 @@
       </p:grpSpPr>
       <p:sp>
         <p:nvSpPr>
-          <p:cNvPr id="451" name="Google Shape;451;p16"/>
+          <p:cNvPr id="494" name="Google Shape;494;p16"/>
           <p:cNvSpPr/>
           <p:nvPr/>
         </p:nvSpPr>
@@ -11338,7 +12365,7 @@
       </p:sp>
       <p:sp>
         <p:nvSpPr>
-          <p:cNvPr id="452" name="Google Shape;452;p16"/>
+          <p:cNvPr id="495" name="Google Shape;495;p16"/>
           <p:cNvSpPr/>
           <p:nvPr/>
         </p:nvSpPr>
@@ -11400,7 +12427,7 @@
       </p:sp>
       <p:sp>
         <p:nvSpPr>
-          <p:cNvPr id="453" name="Google Shape;453;p16"/>
+          <p:cNvPr id="496" name="Google Shape;496;p16"/>
           <p:cNvSpPr/>
           <p:nvPr/>
         </p:nvSpPr>
@@ -11462,7 +12489,7 @@
       </p:sp>
       <p:sp>
         <p:nvSpPr>
-          <p:cNvPr id="454" name="Google Shape;454;p16"/>
+          <p:cNvPr id="497" name="Google Shape;497;p16"/>
           <p:cNvSpPr/>
           <p:nvPr/>
         </p:nvSpPr>
@@ -11524,7 +12551,7 @@
       </p:sp>
       <p:sp>
         <p:nvSpPr>
-          <p:cNvPr id="455" name="Google Shape;455;p16"/>
+          <p:cNvPr id="498" name="Google Shape;498;p16"/>
           <p:cNvSpPr/>
           <p:nvPr/>
         </p:nvSpPr>
@@ -11573,7 +12600,7 @@
       </p:sp>
       <p:sp>
         <p:nvSpPr>
-          <p:cNvPr id="456" name="Google Shape;456;p16"/>
+          <p:cNvPr id="499" name="Google Shape;499;p16"/>
           <p:cNvSpPr/>
           <p:nvPr/>
         </p:nvSpPr>
@@ -11622,7 +12649,7 @@
       </p:sp>
       <p:sp>
         <p:nvSpPr>
-          <p:cNvPr id="457" name="Google Shape;457;p16"/>
+          <p:cNvPr id="500" name="Google Shape;500;p16"/>
           <p:cNvSpPr/>
           <p:nvPr/>
         </p:nvSpPr>
@@ -11665,7 +12692,7 @@
       </p:sp>
       <p:sp>
         <p:nvSpPr>
-          <p:cNvPr id="458" name="Google Shape;458;p16"/>
+          <p:cNvPr id="501" name="Google Shape;501;p16"/>
           <p:cNvSpPr/>
           <p:nvPr/>
         </p:nvSpPr>
@@ -11727,7 +12754,7 @@
       </p:sp>
       <p:sp>
         <p:nvSpPr>
-          <p:cNvPr id="459" name="Google Shape;459;p16"/>
+          <p:cNvPr id="502" name="Google Shape;502;p16"/>
           <p:cNvSpPr/>
           <p:nvPr/>
         </p:nvSpPr>
@@ -11789,7 +12816,7 @@
       </p:sp>
       <p:sp>
         <p:nvSpPr>
-          <p:cNvPr id="460" name="Google Shape;460;p16"/>
+          <p:cNvPr id="503" name="Google Shape;503;p16"/>
           <p:cNvSpPr/>
           <p:nvPr/>
         </p:nvSpPr>
@@ -11883,7 +12910,7 @@
       </p:sp>
       <p:sp>
         <p:nvSpPr>
-          <p:cNvPr id="461" name="Google Shape;461;p16"/>
+          <p:cNvPr id="504" name="Google Shape;504;p16"/>
           <p:cNvSpPr/>
           <p:nvPr/>
         </p:nvSpPr>
@@ -11932,7 +12959,7 @@
       </p:sp>
       <p:sp>
         <p:nvSpPr>
-          <p:cNvPr id="462" name="Google Shape;462;p16"/>
+          <p:cNvPr id="505" name="Google Shape;505;p16"/>
           <p:cNvSpPr/>
           <p:nvPr/>
         </p:nvSpPr>
@@ -11994,7 +13021,7 @@
       </p:sp>
       <p:sp>
         <p:nvSpPr>
-          <p:cNvPr id="463" name="Google Shape;463;p16"/>
+          <p:cNvPr id="506" name="Google Shape;506;p16"/>
           <p:cNvSpPr/>
           <p:nvPr/>
         </p:nvSpPr>
@@ -12037,7 +13064,7 @@
       </p:sp>
       <p:sp>
         <p:nvSpPr>
-          <p:cNvPr id="464" name="Google Shape;464;p16"/>
+          <p:cNvPr id="507" name="Google Shape;507;p16"/>
           <p:cNvSpPr/>
           <p:nvPr/>
         </p:nvSpPr>
@@ -12099,7 +13126,7 @@
       </p:sp>
       <p:sp>
         <p:nvSpPr>
-          <p:cNvPr id="465" name="Google Shape;465;p16"/>
+          <p:cNvPr id="508" name="Google Shape;508;p16"/>
           <p:cNvSpPr/>
           <p:nvPr/>
         </p:nvSpPr>
@@ -12142,7 +13169,7 @@
       </p:sp>
       <p:sp>
         <p:nvSpPr>
-          <p:cNvPr id="466" name="Google Shape;466;p16"/>
+          <p:cNvPr id="509" name="Google Shape;509;p16"/>
           <p:cNvSpPr/>
           <p:nvPr/>
         </p:nvSpPr>
@@ -12204,7 +13231,7 @@
       </p:sp>
       <p:sp>
         <p:nvSpPr>
-          <p:cNvPr id="467" name="Google Shape;467;p16"/>
+          <p:cNvPr id="510" name="Google Shape;510;p16"/>
           <p:cNvSpPr/>
           <p:nvPr/>
         </p:nvSpPr>
@@ -12247,7 +13274,7 @@
       </p:sp>
       <p:sp>
         <p:nvSpPr>
-          <p:cNvPr id="468" name="Google Shape;468;p16"/>
+          <p:cNvPr id="511" name="Google Shape;511;p16"/>
           <p:cNvSpPr/>
           <p:nvPr/>
         </p:nvSpPr>
@@ -12309,7 +13336,7 @@
       </p:sp>
       <p:sp>
         <p:nvSpPr>
-          <p:cNvPr id="469" name="Google Shape;469;p16"/>
+          <p:cNvPr id="512" name="Google Shape;512;p16"/>
           <p:cNvSpPr/>
           <p:nvPr/>
         </p:nvSpPr>
@@ -12358,7 +13385,7 @@
       </p:sp>
       <p:sp>
         <p:nvSpPr>
-          <p:cNvPr id="470" name="Google Shape;470;p16"/>
+          <p:cNvPr id="513" name="Google Shape;513;p16"/>
           <p:cNvSpPr/>
           <p:nvPr/>
         </p:nvSpPr>
@@ -12420,7 +13447,7 @@
       </p:sp>
       <p:sp>
         <p:nvSpPr>
-          <p:cNvPr id="471" name="Google Shape;471;p16"/>
+          <p:cNvPr id="514" name="Google Shape;514;p16"/>
           <p:cNvSpPr/>
           <p:nvPr/>
         </p:nvSpPr>
@@ -12463,7 +13490,7 @@
       </p:sp>
       <p:sp>
         <p:nvSpPr>
-          <p:cNvPr id="472" name="Google Shape;472;p16"/>
+          <p:cNvPr id="515" name="Google Shape;515;p16"/>
           <p:cNvSpPr/>
           <p:nvPr/>
         </p:nvSpPr>
@@ -12525,7 +13552,7 @@
       </p:sp>
       <p:sp>
         <p:nvSpPr>
-          <p:cNvPr id="473" name="Google Shape;473;p16"/>
+          <p:cNvPr id="516" name="Google Shape;516;p16"/>
           <p:cNvSpPr/>
           <p:nvPr/>
         </p:nvSpPr>
@@ -12568,7 +13595,7 @@
       </p:sp>
       <p:sp>
         <p:nvSpPr>
-          <p:cNvPr id="474" name="Google Shape;474;p16"/>
+          <p:cNvPr id="517" name="Google Shape;517;p16"/>
           <p:cNvSpPr/>
           <p:nvPr/>
         </p:nvSpPr>
@@ -12630,7 +13657,7 @@
       </p:sp>
       <p:sp>
         <p:nvSpPr>
-          <p:cNvPr id="475" name="Google Shape;475;p16"/>
+          <p:cNvPr id="518" name="Google Shape;518;p16"/>
           <p:cNvSpPr/>
           <p:nvPr/>
         </p:nvSpPr>
@@ -12673,7 +13700,7 @@
       </p:sp>
       <p:sp>
         <p:nvSpPr>
-          <p:cNvPr id="476" name="Google Shape;476;p16"/>
+          <p:cNvPr id="519" name="Google Shape;519;p16"/>
           <p:cNvSpPr/>
           <p:nvPr/>
         </p:nvSpPr>
@@ -18722,7 +19749,7 @@
         </p:blipFill>
         <p:spPr>
           <a:xfrm>
-            <a:off x="293400" y="1593812"/>
+            <a:off x="293400" y="1602798"/>
             <a:ext cx="4160398" cy="3014183"/>
           </a:xfrm>
           <a:prstGeom prst="rect">
@@ -25972,73 +26999,874 @@
           </a:p>
         </p:txBody>
       </p:sp>
-      <p:pic>
-        <p:nvPicPr>
+      <p:grpSp>
+        <p:nvGrpSpPr>
           <p:cNvPr id="258" name="Google Shape;258;p10"/>
-          <p:cNvPicPr preferRelativeResize="0"/>
-          <p:nvPr/>
-        </p:nvPicPr>
-        <p:blipFill rotWithShape="1">
-          <a:blip r:embed="rId3">
-            <a:alphaModFix/>
-          </a:blip>
-          <a:srcRect b="0" l="0" r="0" t="0"/>
-          <a:stretch/>
-        </p:blipFill>
-        <p:spPr>
-          <a:xfrm>
-            <a:off x="6949440" y="932688"/>
-            <a:ext cx="1965900" cy="1920300"/>
-          </a:xfrm>
-          <a:prstGeom prst="rect">
-            <a:avLst/>
-          </a:prstGeom>
-          <a:noFill/>
-          <a:ln>
+          <p:cNvGrpSpPr/>
+          <p:nvPr/>
+        </p:nvGrpSpPr>
+        <p:grpSpPr>
+          <a:xfrm>
+            <a:off x="6905625" y="932688"/>
+            <a:ext cx="2009715" cy="1877112"/>
+            <a:chOff x="6905625" y="932688"/>
+            <a:chExt cx="2009715" cy="1877112"/>
+          </a:xfrm>
+        </p:grpSpPr>
+        <p:sp>
+          <p:nvSpPr>
+            <p:cNvPr id="259" name="Google Shape;259;p10"/>
+            <p:cNvSpPr txBox="1"/>
+            <p:nvPr/>
+          </p:nvSpPr>
+          <p:spPr>
+            <a:xfrm>
+              <a:off x="6949440" y="932688"/>
+              <a:ext cx="1965900" cy="238200"/>
+            </a:xfrm>
+            <a:prstGeom prst="rect">
+              <a:avLst/>
+            </a:prstGeom>
             <a:noFill/>
-          </a:ln>
-        </p:spPr>
-      </p:pic>
-      <p:sp>
-        <p:nvSpPr>
-          <p:cNvPr id="259" name="Google Shape;259;p10"/>
-          <p:cNvSpPr/>
-          <p:nvPr/>
-        </p:nvSpPr>
-        <p:spPr>
-          <a:xfrm>
-            <a:off x="6949440" y="2871216"/>
-            <a:ext cx="1965900" cy="255900"/>
-          </a:xfrm>
-          <a:prstGeom prst="rect">
-            <a:avLst/>
-          </a:prstGeom>
-          <a:solidFill>
-            <a:srgbClr val="000000">
-              <a:alpha val="0"/>
-            </a:srgbClr>
-          </a:solidFill>
-          <a:ln>
+            <a:ln>
+              <a:noFill/>
+            </a:ln>
+          </p:spPr>
+          <p:txBody>
+            <a:bodyPr anchorCtr="0" anchor="ctr" bIns="0" lIns="0" spcFirstLastPara="1" rIns="0" wrap="square" tIns="0">
+              <a:noAutofit/>
+            </a:bodyPr>
+            <a:lstStyle/>
+            <a:p>
+              <a:pPr indent="0" lvl="0" marL="0" rtl="0" algn="ctr">
+                <a:spcBef>
+                  <a:spcPts val="0"/>
+                </a:spcBef>
+                <a:spcAft>
+                  <a:spcPts val="0"/>
+                </a:spcAft>
+                <a:buNone/>
+              </a:pPr>
+              <a:r>
+                <a:rPr b="1" lang="en" sz="925">
+                  <a:solidFill>
+                    <a:srgbClr val="022369"/>
+                  </a:solidFill>
+                  <a:latin typeface="Montserrat"/>
+                  <a:ea typeface="Montserrat"/>
+                  <a:cs typeface="Montserrat"/>
+                  <a:sym typeface="Montserrat"/>
+                </a:rPr>
+                <a:t>Economic Encoder Comparison</a:t>
+              </a:r>
+              <a:endParaRPr b="1" sz="925">
+                <a:solidFill>
+                  <a:srgbClr val="022369"/>
+                </a:solidFill>
+                <a:latin typeface="Montserrat"/>
+                <a:ea typeface="Montserrat"/>
+                <a:cs typeface="Montserrat"/>
+                <a:sym typeface="Montserrat"/>
+              </a:endParaRPr>
+            </a:p>
+          </p:txBody>
+        </p:sp>
+        <p:sp>
+          <p:nvSpPr>
+            <p:cNvPr id="260" name="Google Shape;260;p10"/>
+            <p:cNvSpPr/>
+            <p:nvPr/>
+          </p:nvSpPr>
+          <p:spPr>
+            <a:xfrm>
+              <a:off x="7239000" y="1238250"/>
+              <a:ext cx="1333500" cy="9600"/>
+            </a:xfrm>
+            <a:prstGeom prst="rect">
+              <a:avLst/>
+            </a:prstGeom>
+            <a:solidFill>
+              <a:srgbClr val="E2E6EA"/>
+            </a:solidFill>
+            <a:ln>
+              <a:noFill/>
+            </a:ln>
+          </p:spPr>
+          <p:txBody>
+            <a:bodyPr anchorCtr="0" anchor="ctr" bIns="0" lIns="0" spcFirstLastPara="1" rIns="0" wrap="square" tIns="0">
+              <a:noAutofit/>
+            </a:bodyPr>
+            <a:lstStyle/>
+            <a:p>
+              <a:pPr indent="0" lvl="0" marL="0" rtl="0" algn="l">
+                <a:spcBef>
+                  <a:spcPts val="0"/>
+                </a:spcBef>
+                <a:spcAft>
+                  <a:spcPts val="0"/>
+                </a:spcAft>
+                <a:buNone/>
+              </a:pPr>
+              <a:r>
+                <a:t/>
+              </a:r>
+              <a:endParaRPr/>
+            </a:p>
+          </p:txBody>
+        </p:sp>
+        <p:sp>
+          <p:nvSpPr>
+            <p:cNvPr id="261" name="Google Shape;261;p10"/>
+            <p:cNvSpPr/>
+            <p:nvPr/>
+          </p:nvSpPr>
+          <p:spPr>
+            <a:xfrm>
+              <a:off x="7239000" y="1524000"/>
+              <a:ext cx="1333500" cy="9600"/>
+            </a:xfrm>
+            <a:prstGeom prst="rect">
+              <a:avLst/>
+            </a:prstGeom>
+            <a:solidFill>
+              <a:srgbClr val="E2E6EA"/>
+            </a:solidFill>
+            <a:ln>
+              <a:noFill/>
+            </a:ln>
+          </p:spPr>
+          <p:txBody>
+            <a:bodyPr anchorCtr="0" anchor="ctr" bIns="0" lIns="0" spcFirstLastPara="1" rIns="0" wrap="square" tIns="0">
+              <a:noAutofit/>
+            </a:bodyPr>
+            <a:lstStyle/>
+            <a:p>
+              <a:pPr indent="0" lvl="0" marL="0" rtl="0" algn="l">
+                <a:spcBef>
+                  <a:spcPts val="0"/>
+                </a:spcBef>
+                <a:spcAft>
+                  <a:spcPts val="0"/>
+                </a:spcAft>
+                <a:buNone/>
+              </a:pPr>
+              <a:r>
+                <a:t/>
+              </a:r>
+              <a:endParaRPr/>
+            </a:p>
+          </p:txBody>
+        </p:sp>
+        <p:sp>
+          <p:nvSpPr>
+            <p:cNvPr id="262" name="Google Shape;262;p10"/>
+            <p:cNvSpPr/>
+            <p:nvPr/>
+          </p:nvSpPr>
+          <p:spPr>
+            <a:xfrm>
+              <a:off x="7239000" y="1809750"/>
+              <a:ext cx="1333500" cy="9600"/>
+            </a:xfrm>
+            <a:prstGeom prst="rect">
+              <a:avLst/>
+            </a:prstGeom>
+            <a:solidFill>
+              <a:srgbClr val="E2E6EA"/>
+            </a:solidFill>
+            <a:ln>
+              <a:noFill/>
+            </a:ln>
+          </p:spPr>
+          <p:txBody>
+            <a:bodyPr anchorCtr="0" anchor="ctr" bIns="0" lIns="0" spcFirstLastPara="1" rIns="0" wrap="square" tIns="0">
+              <a:noAutofit/>
+            </a:bodyPr>
+            <a:lstStyle/>
+            <a:p>
+              <a:pPr indent="0" lvl="0" marL="0" rtl="0" algn="l">
+                <a:spcBef>
+                  <a:spcPts val="0"/>
+                </a:spcBef>
+                <a:spcAft>
+                  <a:spcPts val="0"/>
+                </a:spcAft>
+                <a:buNone/>
+              </a:pPr>
+              <a:r>
+                <a:t/>
+              </a:r>
+              <a:endParaRPr/>
+            </a:p>
+          </p:txBody>
+        </p:sp>
+        <p:sp>
+          <p:nvSpPr>
+            <p:cNvPr id="263" name="Google Shape;263;p10"/>
+            <p:cNvSpPr/>
+            <p:nvPr/>
+          </p:nvSpPr>
+          <p:spPr>
+            <a:xfrm>
+              <a:off x="7239000" y="2095500"/>
+              <a:ext cx="1333500" cy="9600"/>
+            </a:xfrm>
+            <a:prstGeom prst="rect">
+              <a:avLst/>
+            </a:prstGeom>
+            <a:solidFill>
+              <a:srgbClr val="E2E6EA"/>
+            </a:solidFill>
+            <a:ln>
+              <a:noFill/>
+            </a:ln>
+          </p:spPr>
+          <p:txBody>
+            <a:bodyPr anchorCtr="0" anchor="ctr" bIns="0" lIns="0" spcFirstLastPara="1" rIns="0" wrap="square" tIns="0">
+              <a:noAutofit/>
+            </a:bodyPr>
+            <a:lstStyle/>
+            <a:p>
+              <a:pPr indent="0" lvl="0" marL="0" rtl="0" algn="l">
+                <a:spcBef>
+                  <a:spcPts val="0"/>
+                </a:spcBef>
+                <a:spcAft>
+                  <a:spcPts val="0"/>
+                </a:spcAft>
+                <a:buNone/>
+              </a:pPr>
+              <a:r>
+                <a:t/>
+              </a:r>
+              <a:endParaRPr/>
+            </a:p>
+          </p:txBody>
+        </p:sp>
+        <p:sp>
+          <p:nvSpPr>
+            <p:cNvPr id="264" name="Google Shape;264;p10"/>
+            <p:cNvSpPr/>
+            <p:nvPr/>
+          </p:nvSpPr>
+          <p:spPr>
+            <a:xfrm>
+              <a:off x="7239000" y="1238250"/>
+              <a:ext cx="9600" cy="857400"/>
+            </a:xfrm>
+            <a:prstGeom prst="rect">
+              <a:avLst/>
+            </a:prstGeom>
+            <a:solidFill>
+              <a:srgbClr val="2D3142"/>
+            </a:solidFill>
+            <a:ln>
+              <a:noFill/>
+            </a:ln>
+          </p:spPr>
+          <p:txBody>
+            <a:bodyPr anchorCtr="0" anchor="ctr" bIns="0" lIns="0" spcFirstLastPara="1" rIns="0" wrap="square" tIns="0">
+              <a:noAutofit/>
+            </a:bodyPr>
+            <a:lstStyle/>
+            <a:p>
+              <a:pPr indent="0" lvl="0" marL="0" rtl="0" algn="l">
+                <a:spcBef>
+                  <a:spcPts val="0"/>
+                </a:spcBef>
+                <a:spcAft>
+                  <a:spcPts val="0"/>
+                </a:spcAft>
+                <a:buNone/>
+              </a:pPr>
+              <a:r>
+                <a:t/>
+              </a:r>
+              <a:endParaRPr/>
+            </a:p>
+          </p:txBody>
+        </p:sp>
+        <p:grpSp>
+          <p:nvGrpSpPr>
+            <p:cNvPr id="265" name="Google Shape;265;p10"/>
+            <p:cNvGrpSpPr/>
+            <p:nvPr/>
+          </p:nvGrpSpPr>
+          <p:grpSpPr>
+            <a:xfrm>
+              <a:off x="6905625" y="1314450"/>
+              <a:ext cx="695475" cy="171600"/>
+              <a:chOff x="6905625" y="1314450"/>
+              <a:chExt cx="695475" cy="171600"/>
+            </a:xfrm>
+          </p:grpSpPr>
+          <p:sp>
+            <p:nvSpPr>
+              <p:cNvPr id="266" name="Google Shape;266;p10"/>
+              <p:cNvSpPr/>
+              <p:nvPr/>
+            </p:nvSpPr>
+            <p:spPr>
+              <a:xfrm>
+                <a:off x="7239000" y="1314450"/>
+                <a:ext cx="57300" cy="171600"/>
+              </a:xfrm>
+              <a:prstGeom prst="rect">
+                <a:avLst/>
+              </a:prstGeom>
+              <a:solidFill>
+                <a:srgbClr val="017EFF"/>
+              </a:solidFill>
+              <a:ln>
+                <a:noFill/>
+              </a:ln>
+            </p:spPr>
+            <p:txBody>
+              <a:bodyPr anchorCtr="0" anchor="ctr" bIns="0" lIns="0" spcFirstLastPara="1" rIns="0" wrap="square" tIns="0">
+                <a:noAutofit/>
+              </a:bodyPr>
+              <a:lstStyle/>
+              <a:p>
+                <a:pPr indent="0" lvl="0" marL="0" rtl="0" algn="l">
+                  <a:spcBef>
+                    <a:spcPts val="0"/>
+                  </a:spcBef>
+                  <a:spcAft>
+                    <a:spcPts val="0"/>
+                  </a:spcAft>
+                  <a:buNone/>
+                </a:pPr>
+                <a:r>
+                  <a:t/>
+                </a:r>
+                <a:endParaRPr/>
+              </a:p>
+            </p:txBody>
+          </p:sp>
+          <p:sp>
+            <p:nvSpPr>
+              <p:cNvPr id="267" name="Google Shape;267;p10"/>
+              <p:cNvSpPr txBox="1"/>
+              <p:nvPr/>
+            </p:nvSpPr>
+            <p:spPr>
+              <a:xfrm>
+                <a:off x="7315200" y="1314450"/>
+                <a:ext cx="285900" cy="171600"/>
+              </a:xfrm>
+              <a:prstGeom prst="rect">
+                <a:avLst/>
+              </a:prstGeom>
+              <a:noFill/>
+              <a:ln>
+                <a:noFill/>
+              </a:ln>
+            </p:spPr>
+            <p:txBody>
+              <a:bodyPr anchorCtr="0" anchor="ctr" bIns="0" lIns="0" spcFirstLastPara="1" rIns="0" wrap="square" tIns="0">
+                <a:noAutofit/>
+              </a:bodyPr>
+              <a:lstStyle/>
+              <a:p>
+                <a:pPr indent="0" lvl="0" marL="0" rtl="0" algn="l">
+                  <a:spcBef>
+                    <a:spcPts val="0"/>
+                  </a:spcBef>
+                  <a:spcAft>
+                    <a:spcPts val="0"/>
+                  </a:spcAft>
+                  <a:buNone/>
+                </a:pPr>
+                <a:r>
+                  <a:rPr b="1" lang="en" sz="700">
+                    <a:solidFill>
+                      <a:srgbClr val="2D3142"/>
+                    </a:solidFill>
+                    <a:latin typeface="Montserrat"/>
+                    <a:ea typeface="Montserrat"/>
+                    <a:cs typeface="Montserrat"/>
+                    <a:sym typeface="Montserrat"/>
+                  </a:rPr>
+                  <a:t>0.056</a:t>
+                </a:r>
+                <a:endParaRPr b="1" sz="700">
+                  <a:solidFill>
+                    <a:srgbClr val="2D3142"/>
+                  </a:solidFill>
+                  <a:latin typeface="Montserrat"/>
+                  <a:ea typeface="Montserrat"/>
+                  <a:cs typeface="Montserrat"/>
+                  <a:sym typeface="Montserrat"/>
+                </a:endParaRPr>
+              </a:p>
+            </p:txBody>
+          </p:sp>
+          <p:sp>
+            <p:nvSpPr>
+              <p:cNvPr id="268" name="Google Shape;268;p10"/>
+              <p:cNvSpPr txBox="1"/>
+              <p:nvPr/>
+            </p:nvSpPr>
+            <p:spPr>
+              <a:xfrm>
+                <a:off x="6905625" y="1314450"/>
+                <a:ext cx="285900" cy="171600"/>
+              </a:xfrm>
+              <a:prstGeom prst="rect">
+                <a:avLst/>
+              </a:prstGeom>
+              <a:noFill/>
+              <a:ln>
+                <a:noFill/>
+              </a:ln>
+            </p:spPr>
+            <p:txBody>
+              <a:bodyPr anchorCtr="0" anchor="ctr" bIns="0" lIns="0" spcFirstLastPara="1" rIns="0" wrap="square" tIns="0">
+                <a:noAutofit/>
+              </a:bodyPr>
+              <a:lstStyle/>
+              <a:p>
+                <a:pPr indent="0" lvl="0" marL="0" rtl="0" algn="r">
+                  <a:spcBef>
+                    <a:spcPts val="0"/>
+                  </a:spcBef>
+                  <a:spcAft>
+                    <a:spcPts val="0"/>
+                  </a:spcAft>
+                  <a:buNone/>
+                </a:pPr>
+                <a:r>
+                  <a:rPr b="0" lang="en" sz="700">
+                    <a:solidFill>
+                      <a:srgbClr val="6B7280"/>
+                    </a:solidFill>
+                    <a:latin typeface="Montserrat"/>
+                    <a:ea typeface="Montserrat"/>
+                    <a:cs typeface="Montserrat"/>
+                    <a:sym typeface="Montserrat"/>
+                  </a:rPr>
+                  <a:t>MLP</a:t>
+                </a:r>
+                <a:endParaRPr b="0" sz="700">
+                  <a:solidFill>
+                    <a:srgbClr val="6B7280"/>
+                  </a:solidFill>
+                  <a:latin typeface="Montserrat"/>
+                  <a:ea typeface="Montserrat"/>
+                  <a:cs typeface="Montserrat"/>
+                  <a:sym typeface="Montserrat"/>
+                </a:endParaRPr>
+              </a:p>
+            </p:txBody>
+          </p:sp>
+        </p:grpSp>
+        <p:grpSp>
+          <p:nvGrpSpPr>
+            <p:cNvPr id="269" name="Google Shape;269;p10"/>
+            <p:cNvGrpSpPr/>
+            <p:nvPr/>
+          </p:nvGrpSpPr>
+          <p:grpSpPr>
+            <a:xfrm>
+              <a:off x="6905625" y="1600200"/>
+              <a:ext cx="1743225" cy="171600"/>
+              <a:chOff x="6905625" y="1600200"/>
+              <a:chExt cx="1743225" cy="171600"/>
+            </a:xfrm>
+          </p:grpSpPr>
+          <p:sp>
+            <p:nvSpPr>
+              <p:cNvPr id="270" name="Google Shape;270;p10"/>
+              <p:cNvSpPr/>
+              <p:nvPr/>
+            </p:nvSpPr>
+            <p:spPr>
+              <a:xfrm>
+                <a:off x="7239000" y="1600200"/>
+                <a:ext cx="1095300" cy="171600"/>
+              </a:xfrm>
+              <a:prstGeom prst="rect">
+                <a:avLst/>
+              </a:prstGeom>
+              <a:solidFill>
+                <a:srgbClr val="EBF3FF"/>
+              </a:solidFill>
+              <a:ln cap="flat" cmpd="sng" w="4775">
+                <a:solidFill>
+                  <a:srgbClr val="017EFF"/>
+                </a:solidFill>
+                <a:prstDash val="solid"/>
+                <a:round/>
+                <a:headEnd len="sm" w="sm" type="none"/>
+                <a:tailEnd len="sm" w="sm" type="none"/>
+              </a:ln>
+            </p:spPr>
+            <p:txBody>
+              <a:bodyPr anchorCtr="0" anchor="ctr" bIns="0" lIns="0" spcFirstLastPara="1" rIns="0" wrap="square" tIns="0">
+                <a:noAutofit/>
+              </a:bodyPr>
+              <a:lstStyle/>
+              <a:p>
+                <a:pPr indent="0" lvl="0" marL="0" rtl="0" algn="l">
+                  <a:spcBef>
+                    <a:spcPts val="0"/>
+                  </a:spcBef>
+                  <a:spcAft>
+                    <a:spcPts val="0"/>
+                  </a:spcAft>
+                  <a:buNone/>
+                </a:pPr>
+                <a:r>
+                  <a:t/>
+                </a:r>
+                <a:endParaRPr/>
+              </a:p>
+            </p:txBody>
+          </p:sp>
+          <p:sp>
+            <p:nvSpPr>
+              <p:cNvPr id="271" name="Google Shape;271;p10"/>
+              <p:cNvSpPr txBox="1"/>
+              <p:nvPr/>
+            </p:nvSpPr>
+            <p:spPr>
+              <a:xfrm>
+                <a:off x="8362950" y="1600200"/>
+                <a:ext cx="285900" cy="171600"/>
+              </a:xfrm>
+              <a:prstGeom prst="rect">
+                <a:avLst/>
+              </a:prstGeom>
+              <a:noFill/>
+              <a:ln>
+                <a:noFill/>
+              </a:ln>
+            </p:spPr>
+            <p:txBody>
+              <a:bodyPr anchorCtr="0" anchor="ctr" bIns="0" lIns="0" spcFirstLastPara="1" rIns="0" wrap="square" tIns="0">
+                <a:noAutofit/>
+              </a:bodyPr>
+              <a:lstStyle/>
+              <a:p>
+                <a:pPr indent="0" lvl="0" marL="0" rtl="0" algn="l">
+                  <a:spcBef>
+                    <a:spcPts val="0"/>
+                  </a:spcBef>
+                  <a:spcAft>
+                    <a:spcPts val="0"/>
+                  </a:spcAft>
+                  <a:buNone/>
+                </a:pPr>
+                <a:r>
+                  <a:rPr b="0" lang="en" sz="700">
+                    <a:solidFill>
+                      <a:srgbClr val="6B7280"/>
+                    </a:solidFill>
+                    <a:latin typeface="Montserrat"/>
+                    <a:ea typeface="Montserrat"/>
+                    <a:cs typeface="Montserrat"/>
+                    <a:sym typeface="Montserrat"/>
+                  </a:rPr>
+                  <a:t>1.081</a:t>
+                </a:r>
+                <a:endParaRPr b="0" sz="700">
+                  <a:solidFill>
+                    <a:srgbClr val="6B7280"/>
+                  </a:solidFill>
+                  <a:latin typeface="Montserrat"/>
+                  <a:ea typeface="Montserrat"/>
+                  <a:cs typeface="Montserrat"/>
+                  <a:sym typeface="Montserrat"/>
+                </a:endParaRPr>
+              </a:p>
+            </p:txBody>
+          </p:sp>
+          <p:sp>
+            <p:nvSpPr>
+              <p:cNvPr id="272" name="Google Shape;272;p10"/>
+              <p:cNvSpPr txBox="1"/>
+              <p:nvPr/>
+            </p:nvSpPr>
+            <p:spPr>
+              <a:xfrm>
+                <a:off x="6905625" y="1600200"/>
+                <a:ext cx="285900" cy="171600"/>
+              </a:xfrm>
+              <a:prstGeom prst="rect">
+                <a:avLst/>
+              </a:prstGeom>
+              <a:noFill/>
+              <a:ln>
+                <a:noFill/>
+              </a:ln>
+            </p:spPr>
+            <p:txBody>
+              <a:bodyPr anchorCtr="0" anchor="ctr" bIns="0" lIns="0" spcFirstLastPara="1" rIns="0" wrap="square" tIns="0">
+                <a:noAutofit/>
+              </a:bodyPr>
+              <a:lstStyle/>
+              <a:p>
+                <a:pPr indent="0" lvl="0" marL="0" rtl="0" algn="r">
+                  <a:spcBef>
+                    <a:spcPts val="0"/>
+                  </a:spcBef>
+                  <a:spcAft>
+                    <a:spcPts val="0"/>
+                  </a:spcAft>
+                  <a:buNone/>
+                </a:pPr>
+                <a:r>
+                  <a:rPr b="0" lang="en" sz="700">
+                    <a:solidFill>
+                      <a:srgbClr val="6B7280"/>
+                    </a:solidFill>
+                    <a:latin typeface="Montserrat"/>
+                    <a:ea typeface="Montserrat"/>
+                    <a:cs typeface="Montserrat"/>
+                    <a:sym typeface="Montserrat"/>
+                  </a:rPr>
+                  <a:t>GRU</a:t>
+                </a:r>
+                <a:endParaRPr b="0" sz="700">
+                  <a:solidFill>
+                    <a:srgbClr val="6B7280"/>
+                  </a:solidFill>
+                  <a:latin typeface="Montserrat"/>
+                  <a:ea typeface="Montserrat"/>
+                  <a:cs typeface="Montserrat"/>
+                  <a:sym typeface="Montserrat"/>
+                </a:endParaRPr>
+              </a:p>
+            </p:txBody>
+          </p:sp>
+        </p:grpSp>
+        <p:grpSp>
+          <p:nvGrpSpPr>
+            <p:cNvPr id="273" name="Google Shape;273;p10"/>
+            <p:cNvGrpSpPr/>
+            <p:nvPr/>
+          </p:nvGrpSpPr>
+          <p:grpSpPr>
+            <a:xfrm>
+              <a:off x="6905625" y="1885950"/>
+              <a:ext cx="1857525" cy="171600"/>
+              <a:chOff x="6905625" y="1885950"/>
+              <a:chExt cx="1857525" cy="171600"/>
+            </a:xfrm>
+          </p:grpSpPr>
+          <p:sp>
+            <p:nvSpPr>
+              <p:cNvPr id="274" name="Google Shape;274;p10"/>
+              <p:cNvSpPr/>
+              <p:nvPr/>
+            </p:nvSpPr>
+            <p:spPr>
+              <a:xfrm>
+                <a:off x="7239000" y="1885950"/>
+                <a:ext cx="1209600" cy="171600"/>
+              </a:xfrm>
+              <a:prstGeom prst="rect">
+                <a:avLst/>
+              </a:prstGeom>
+              <a:solidFill>
+                <a:srgbClr val="EBF3FF"/>
+              </a:solidFill>
+              <a:ln cap="flat" cmpd="sng" w="4775">
+                <a:solidFill>
+                  <a:srgbClr val="017EFF"/>
+                </a:solidFill>
+                <a:prstDash val="solid"/>
+                <a:round/>
+                <a:headEnd len="sm" w="sm" type="none"/>
+                <a:tailEnd len="sm" w="sm" type="none"/>
+              </a:ln>
+            </p:spPr>
+            <p:txBody>
+              <a:bodyPr anchorCtr="0" anchor="ctr" bIns="0" lIns="0" spcFirstLastPara="1" rIns="0" wrap="square" tIns="0">
+                <a:noAutofit/>
+              </a:bodyPr>
+              <a:lstStyle/>
+              <a:p>
+                <a:pPr indent="0" lvl="0" marL="0" rtl="0" algn="l">
+                  <a:spcBef>
+                    <a:spcPts val="0"/>
+                  </a:spcBef>
+                  <a:spcAft>
+                    <a:spcPts val="0"/>
+                  </a:spcAft>
+                  <a:buNone/>
+                </a:pPr>
+                <a:r>
+                  <a:t/>
+                </a:r>
+                <a:endParaRPr/>
+              </a:p>
+            </p:txBody>
+          </p:sp>
+          <p:sp>
+            <p:nvSpPr>
+              <p:cNvPr id="275" name="Google Shape;275;p10"/>
+              <p:cNvSpPr txBox="1"/>
+              <p:nvPr/>
+            </p:nvSpPr>
+            <p:spPr>
+              <a:xfrm>
+                <a:off x="8477250" y="1885950"/>
+                <a:ext cx="285900" cy="171600"/>
+              </a:xfrm>
+              <a:prstGeom prst="rect">
+                <a:avLst/>
+              </a:prstGeom>
+              <a:noFill/>
+              <a:ln>
+                <a:noFill/>
+              </a:ln>
+            </p:spPr>
+            <p:txBody>
+              <a:bodyPr anchorCtr="0" anchor="ctr" bIns="0" lIns="0" spcFirstLastPara="1" rIns="0" wrap="square" tIns="0">
+                <a:noAutofit/>
+              </a:bodyPr>
+              <a:lstStyle/>
+              <a:p>
+                <a:pPr indent="0" lvl="0" marL="0" rtl="0" algn="l">
+                  <a:spcBef>
+                    <a:spcPts val="0"/>
+                  </a:spcBef>
+                  <a:spcAft>
+                    <a:spcPts val="0"/>
+                  </a:spcAft>
+                  <a:buNone/>
+                </a:pPr>
+                <a:r>
+                  <a:rPr b="0" lang="en" sz="700">
+                    <a:solidFill>
+                      <a:srgbClr val="6B7280"/>
+                    </a:solidFill>
+                    <a:latin typeface="Montserrat"/>
+                    <a:ea typeface="Montserrat"/>
+                    <a:cs typeface="Montserrat"/>
+                    <a:sym typeface="Montserrat"/>
+                  </a:rPr>
+                  <a:t>1.192</a:t>
+                </a:r>
+                <a:endParaRPr b="0" sz="700">
+                  <a:solidFill>
+                    <a:srgbClr val="6B7280"/>
+                  </a:solidFill>
+                  <a:latin typeface="Montserrat"/>
+                  <a:ea typeface="Montserrat"/>
+                  <a:cs typeface="Montserrat"/>
+                  <a:sym typeface="Montserrat"/>
+                </a:endParaRPr>
+              </a:p>
+            </p:txBody>
+          </p:sp>
+          <p:sp>
+            <p:nvSpPr>
+              <p:cNvPr id="276" name="Google Shape;276;p10"/>
+              <p:cNvSpPr txBox="1"/>
+              <p:nvPr/>
+            </p:nvSpPr>
+            <p:spPr>
+              <a:xfrm>
+                <a:off x="6905625" y="1885950"/>
+                <a:ext cx="285900" cy="171600"/>
+              </a:xfrm>
+              <a:prstGeom prst="rect">
+                <a:avLst/>
+              </a:prstGeom>
+              <a:noFill/>
+              <a:ln>
+                <a:noFill/>
+              </a:ln>
+            </p:spPr>
+            <p:txBody>
+              <a:bodyPr anchorCtr="0" anchor="ctr" bIns="0" lIns="0" spcFirstLastPara="1" rIns="0" wrap="square" tIns="0">
+                <a:noAutofit/>
+              </a:bodyPr>
+              <a:lstStyle/>
+              <a:p>
+                <a:pPr indent="0" lvl="0" marL="0" rtl="0" algn="r">
+                  <a:spcBef>
+                    <a:spcPts val="0"/>
+                  </a:spcBef>
+                  <a:spcAft>
+                    <a:spcPts val="0"/>
+                  </a:spcAft>
+                  <a:buNone/>
+                </a:pPr>
+                <a:r>
+                  <a:rPr b="0" lang="en" sz="700">
+                    <a:solidFill>
+                      <a:srgbClr val="6B7280"/>
+                    </a:solidFill>
+                    <a:latin typeface="Montserrat"/>
+                    <a:ea typeface="Montserrat"/>
+                    <a:cs typeface="Montserrat"/>
+                    <a:sym typeface="Montserrat"/>
+                  </a:rPr>
+                  <a:t>LSTM</a:t>
+                </a:r>
+                <a:endParaRPr b="0" sz="700">
+                  <a:solidFill>
+                    <a:srgbClr val="6B7280"/>
+                  </a:solidFill>
+                  <a:latin typeface="Montserrat"/>
+                  <a:ea typeface="Montserrat"/>
+                  <a:cs typeface="Montserrat"/>
+                  <a:sym typeface="Montserrat"/>
+                </a:endParaRPr>
+              </a:p>
+            </p:txBody>
+          </p:sp>
+        </p:grpSp>
+        <p:sp>
+          <p:nvSpPr>
+            <p:cNvPr id="277" name="Google Shape;277;p10"/>
+            <p:cNvSpPr txBox="1"/>
+            <p:nvPr/>
+          </p:nvSpPr>
+          <p:spPr>
+            <a:xfrm>
+              <a:off x="6949440" y="2238375"/>
+              <a:ext cx="1965900" cy="142800"/>
+            </a:xfrm>
+            <a:prstGeom prst="rect">
+              <a:avLst/>
+            </a:prstGeom>
             <a:noFill/>
-          </a:ln>
-        </p:spPr>
-        <p:txBody>
-          <a:bodyPr anchorCtr="0" anchor="ctr" bIns="45700" lIns="91425" spcFirstLastPara="1" rIns="91425" wrap="square" tIns="45700">
-            <a:noAutofit/>
-          </a:bodyPr>
-          <a:lstStyle/>
-          <a:p>
-            <a:pPr indent="0" lvl="0" marL="0" rtl="0" algn="ctr">
-              <a:spcBef>
-                <a:spcPts val="0"/>
-              </a:spcBef>
-              <a:spcAft>
-                <a:spcPts val="0"/>
-              </a:spcAft>
-              <a:buNone/>
-            </a:pPr>
-            <a:r>
-              <a:rPr b="0" i="1" lang="en" sz="853">
+            <a:ln>
+              <a:noFill/>
+            </a:ln>
+          </p:spPr>
+          <p:txBody>
+            <a:bodyPr anchorCtr="0" anchor="ctr" bIns="0" lIns="0" spcFirstLastPara="1" rIns="0" wrap="square" tIns="0">
+              <a:noAutofit/>
+            </a:bodyPr>
+            <a:lstStyle/>
+            <a:p>
+              <a:pPr indent="0" lvl="0" marL="0" rtl="0" algn="ctr">
+                <a:spcBef>
+                  <a:spcPts val="0"/>
+                </a:spcBef>
+                <a:spcAft>
+                  <a:spcPts val="0"/>
+                </a:spcAft>
+                <a:buNone/>
+              </a:pPr>
+              <a:r>
+                <a:rPr b="0" lang="en" sz="700">
+                  <a:solidFill>
+                    <a:srgbClr val="6B7280"/>
+                  </a:solidFill>
+                  <a:latin typeface="Montserrat"/>
+                  <a:ea typeface="Montserrat"/>
+                  <a:cs typeface="Montserrat"/>
+                  <a:sym typeface="Montserrat"/>
+                </a:rPr>
+                <a:t>2021-2023 reconstruction MSE</a:t>
+              </a:r>
+              <a:endParaRPr b="0" sz="700">
                 <a:solidFill>
                   <a:srgbClr val="6B7280"/>
                 </a:solidFill>
@@ -26046,24 +27874,72 @@
                 <a:ea typeface="Montserrat"/>
                 <a:cs typeface="Montserrat"/>
                 <a:sym typeface="Montserrat"/>
-              </a:rPr>
-              <a:t>Test MSE - MLP wins decisively</a:t>
-            </a:r>
-            <a:endParaRPr b="0" i="1" sz="853">
-              <a:solidFill>
-                <a:srgbClr val="6B7280"/>
-              </a:solidFill>
-              <a:latin typeface="Montserrat"/>
-              <a:ea typeface="Montserrat"/>
-              <a:cs typeface="Montserrat"/>
-              <a:sym typeface="Montserrat"/>
-            </a:endParaRPr>
-          </a:p>
-        </p:txBody>
-      </p:sp>
-      <p:sp>
-        <p:nvSpPr>
-          <p:cNvPr id="260" name="Google Shape;260;p10"/>
+              </a:endParaRPr>
+            </a:p>
+          </p:txBody>
+        </p:sp>
+        <p:sp>
+          <p:nvSpPr>
+            <p:cNvPr id="278" name="Google Shape;278;p10"/>
+            <p:cNvSpPr txBox="1"/>
+            <p:nvPr/>
+          </p:nvSpPr>
+          <p:spPr>
+            <a:xfrm>
+              <a:off x="6949440" y="2476500"/>
+              <a:ext cx="1965900" cy="333300"/>
+            </a:xfrm>
+            <a:prstGeom prst="rect">
+              <a:avLst/>
+            </a:prstGeom>
+            <a:noFill/>
+            <a:ln>
+              <a:noFill/>
+            </a:ln>
+          </p:spPr>
+          <p:txBody>
+            <a:bodyPr anchorCtr="0" anchor="t" bIns="0" lIns="0" spcFirstLastPara="1" rIns="0" wrap="square" tIns="0">
+              <a:noAutofit/>
+            </a:bodyPr>
+            <a:lstStyle/>
+            <a:p>
+              <a:pPr indent="0" lvl="0" marL="0" rtl="0" algn="ctr">
+                <a:spcBef>
+                  <a:spcPts val="0"/>
+                </a:spcBef>
+                <a:spcAft>
+                  <a:spcPts val="0"/>
+                </a:spcAft>
+                <a:buNone/>
+              </a:pPr>
+              <a:r>
+                <a:rPr b="0" i="1" lang="en" sz="750">
+                  <a:solidFill>
+                    <a:srgbClr val="6B7280"/>
+                  </a:solidFill>
+                  <a:latin typeface="Montserrat"/>
+                  <a:ea typeface="Montserrat"/>
+                  <a:cs typeface="Montserrat"/>
+                  <a:sym typeface="Montserrat"/>
+                </a:rPr>
+                <a:t>Lower is better. MLP has the lowest holdout reconstruction error.</a:t>
+              </a:r>
+              <a:endParaRPr b="0" i="1" sz="750">
+                <a:solidFill>
+                  <a:srgbClr val="6B7280"/>
+                </a:solidFill>
+                <a:latin typeface="Montserrat"/>
+                <a:ea typeface="Montserrat"/>
+                <a:cs typeface="Montserrat"/>
+                <a:sym typeface="Montserrat"/>
+              </a:endParaRPr>
+            </a:p>
+          </p:txBody>
+        </p:sp>
+      </p:grpSp>
+      <p:sp>
+        <p:nvSpPr>
+          <p:cNvPr id="279" name="Google Shape;279;p10"/>
           <p:cNvSpPr/>
           <p:nvPr/>
         </p:nvSpPr>
@@ -26112,7 +27988,7 @@
       </p:sp>
       <p:sp>
         <p:nvSpPr>
-          <p:cNvPr id="261" name="Google Shape;261;p10"/>
+          <p:cNvPr id="280" name="Google Shape;280;p10"/>
           <p:cNvSpPr/>
           <p:nvPr/>
         </p:nvSpPr>
@@ -26174,7 +28050,7 @@
       </p:sp>
       <p:sp>
         <p:nvSpPr>
-          <p:cNvPr id="262" name="Google Shape;262;p10"/>
+          <p:cNvPr id="281" name="Google Shape;281;p10"/>
           <p:cNvSpPr/>
           <p:nvPr/>
         </p:nvSpPr>
@@ -26223,7 +28099,7 @@
       </p:sp>
       <p:sp>
         <p:nvSpPr>
-          <p:cNvPr id="263" name="Google Shape;263;p10"/>
+          <p:cNvPr id="282" name="Google Shape;282;p10"/>
           <p:cNvSpPr/>
           <p:nvPr/>
         </p:nvSpPr>
@@ -26285,7 +28161,7 @@
       </p:sp>
       <p:sp>
         <p:nvSpPr>
-          <p:cNvPr id="264" name="Google Shape;264;p10"/>
+          <p:cNvPr id="283" name="Google Shape;283;p10"/>
           <p:cNvSpPr/>
           <p:nvPr/>
         </p:nvSpPr>
@@ -26331,7 +28207,31 @@
                 <a:cs typeface="Montserrat"/>
                 <a:sym typeface="Montserrat"/>
               </a:rPr>
-              <a:t>ResNet-50 BCE+Dice loss LR 3e-4 40 epochs batch 16</a:t>
+              <a:t>ResNet-</a:t>
+            </a:r>
+            <a:r>
+              <a:rPr lang="en" sz="1200">
+                <a:solidFill>
+                  <a:srgbClr val="2D3142"/>
+                </a:solidFill>
+                <a:latin typeface="Montserrat"/>
+                <a:ea typeface="Montserrat"/>
+                <a:cs typeface="Montserrat"/>
+                <a:sym typeface="Montserrat"/>
+              </a:rPr>
+              <a:t>18</a:t>
+            </a:r>
+            <a:r>
+              <a:rPr b="0" lang="en" sz="1200">
+                <a:solidFill>
+                  <a:srgbClr val="2D3142"/>
+                </a:solidFill>
+                <a:latin typeface="Montserrat"/>
+                <a:ea typeface="Montserrat"/>
+                <a:cs typeface="Montserrat"/>
+                <a:sym typeface="Montserrat"/>
+              </a:rPr>
+              <a:t> BCE+Dice loss LR 3e-4 40 epochs batch 16</a:t>
             </a:r>
             <a:endParaRPr b="0" sz="1200">
               <a:solidFill>
@@ -26347,7 +28247,7 @@
       </p:sp>
       <p:sp>
         <p:nvSpPr>
-          <p:cNvPr id="265" name="Google Shape;265;p10"/>
+          <p:cNvPr id="284" name="Google Shape;284;p10"/>
           <p:cNvSpPr/>
           <p:nvPr/>
         </p:nvSpPr>
@@ -26396,7 +28296,7 @@
       </p:sp>
       <p:sp>
         <p:nvSpPr>
-          <p:cNvPr id="266" name="Google Shape;266;p10"/>
+          <p:cNvPr id="285" name="Google Shape;285;p10"/>
           <p:cNvSpPr/>
           <p:nvPr/>
         </p:nvSpPr>
@@ -26458,7 +28358,7 @@
       </p:sp>
       <p:sp>
         <p:nvSpPr>
-          <p:cNvPr id="267" name="Google Shape;267;p10"/>
+          <p:cNvPr id="286" name="Google Shape;286;p10"/>
           <p:cNvSpPr/>
           <p:nvPr/>
         </p:nvSpPr>
@@ -26520,7 +28420,7 @@
       </p:sp>
       <p:sp>
         <p:nvSpPr>
-          <p:cNvPr id="268" name="Google Shape;268;p10"/>
+          <p:cNvPr id="287" name="Google Shape;287;p10"/>
           <p:cNvSpPr/>
           <p:nvPr/>
         </p:nvSpPr>
@@ -26569,7 +28469,7 @@
       </p:sp>
       <p:sp>
         <p:nvSpPr>
-          <p:cNvPr id="269" name="Google Shape;269;p10"/>
+          <p:cNvPr id="288" name="Google Shape;288;p10"/>
           <p:cNvSpPr/>
           <p:nvPr/>
         </p:nvSpPr>
@@ -26631,7 +28531,7 @@
       </p:sp>
       <p:sp>
         <p:nvSpPr>
-          <p:cNvPr id="270" name="Google Shape;270;p10"/>
+          <p:cNvPr id="289" name="Google Shape;289;p10"/>
           <p:cNvSpPr/>
           <p:nvPr/>
         </p:nvSpPr>
@@ -26711,7 +28611,7 @@
     </p:bg>
     <p:spTree>
       <p:nvGrpSpPr>
-        <p:cNvPr id="275" name="Shape 275"/>
+        <p:cNvPr id="294" name="Shape 294"/>
         <p:cNvGrpSpPr/>
         <p:nvPr/>
       </p:nvGrpSpPr>
@@ -26725,7 +28625,7 @@
       </p:grpSpPr>
       <p:sp>
         <p:nvSpPr>
-          <p:cNvPr id="276" name="Google Shape;276;p11"/>
+          <p:cNvPr id="295" name="Google Shape;295;p11"/>
           <p:cNvSpPr/>
           <p:nvPr/>
         </p:nvSpPr>
@@ -26774,7 +28674,7 @@
       </p:sp>
       <p:sp>
         <p:nvSpPr>
-          <p:cNvPr id="277" name="Google Shape;277;p11"/>
+          <p:cNvPr id="296" name="Google Shape;296;p11"/>
           <p:cNvSpPr/>
           <p:nvPr/>
         </p:nvSpPr>
@@ -26837,7 +28737,7 @@
       </p:sp>
       <p:sp>
         <p:nvSpPr>
-          <p:cNvPr id="278" name="Google Shape;278;p11"/>
+          <p:cNvPr id="297" name="Google Shape;297;p11"/>
           <p:cNvSpPr/>
           <p:nvPr/>
         </p:nvSpPr>
@@ -26900,7 +28800,7 @@
       </p:sp>
       <p:sp>
         <p:nvSpPr>
-          <p:cNvPr id="279" name="Google Shape;279;p11"/>
+          <p:cNvPr id="298" name="Google Shape;298;p11"/>
           <p:cNvSpPr/>
           <p:nvPr/>
         </p:nvSpPr>
@@ -27024,7 +28924,7 @@
       </p:sp>
       <p:sp>
         <p:nvSpPr>
-          <p:cNvPr id="280" name="Google Shape;280;p11"/>
+          <p:cNvPr id="299" name="Google Shape;299;p11"/>
           <p:cNvSpPr/>
           <p:nvPr/>
         </p:nvSpPr>
@@ -27073,7 +28973,7 @@
       </p:sp>
       <p:sp>
         <p:nvSpPr>
-          <p:cNvPr id="281" name="Google Shape;281;p11"/>
+          <p:cNvPr id="300" name="Google Shape;300;p11"/>
           <p:cNvSpPr/>
           <p:nvPr/>
         </p:nvSpPr>
@@ -27122,7 +29022,7 @@
       </p:sp>
       <p:sp>
         <p:nvSpPr>
-          <p:cNvPr id="282" name="Google Shape;282;p11"/>
+          <p:cNvPr id="301" name="Google Shape;301;p11"/>
           <p:cNvSpPr/>
           <p:nvPr/>
         </p:nvSpPr>
@@ -27184,7 +29084,7 @@
       </p:sp>
       <p:sp>
         <p:nvSpPr>
-          <p:cNvPr id="283" name="Google Shape;283;p11"/>
+          <p:cNvPr id="302" name="Google Shape;302;p11"/>
           <p:cNvSpPr/>
           <p:nvPr/>
         </p:nvSpPr>
@@ -27230,7 +29130,31 @@
                 <a:cs typeface="Montserrat"/>
                 <a:sym typeface="Montserrat"/>
               </a:rPr>
-              <a:t>z_img (ResNet-50, GHSL-finetuned)</a:t>
+              <a:t>z_img (ResNet-</a:t>
+            </a:r>
+            <a:r>
+              <a:rPr i="1" lang="en" sz="1000">
+                <a:solidFill>
+                  <a:srgbClr val="6B7280"/>
+                </a:solidFill>
+                <a:latin typeface="Montserrat"/>
+                <a:ea typeface="Montserrat"/>
+                <a:cs typeface="Montserrat"/>
+                <a:sym typeface="Montserrat"/>
+              </a:rPr>
+              <a:t>18,</a:t>
+            </a:r>
+            <a:r>
+              <a:rPr b="0" i="1" lang="en" sz="1000">
+                <a:solidFill>
+                  <a:srgbClr val="6B7280"/>
+                </a:solidFill>
+                <a:latin typeface="Montserrat"/>
+                <a:ea typeface="Montserrat"/>
+                <a:cs typeface="Montserrat"/>
+                <a:sym typeface="Montserrat"/>
+              </a:rPr>
+              <a:t>, GHSL-finetuned)</a:t>
             </a:r>
             <a:endParaRPr b="0" i="1" sz="1000">
               <a:solidFill>
@@ -27246,7 +29170,7 @@
       </p:sp>
       <p:sp>
         <p:nvSpPr>
-          <p:cNvPr id="284" name="Google Shape;284;p11"/>
+          <p:cNvPr id="303" name="Google Shape;303;p11"/>
           <p:cNvSpPr/>
           <p:nvPr/>
         </p:nvSpPr>
@@ -27295,7 +29219,7 @@
       </p:sp>
       <p:sp>
         <p:nvSpPr>
-          <p:cNvPr id="285" name="Google Shape;285;p11"/>
+          <p:cNvPr id="304" name="Google Shape;304;p11"/>
           <p:cNvSpPr/>
           <p:nvPr/>
         </p:nvSpPr>
@@ -27357,7 +29281,7 @@
       </p:sp>
       <p:sp>
         <p:nvSpPr>
-          <p:cNvPr id="286" name="Google Shape;286;p11"/>
+          <p:cNvPr id="305" name="Google Shape;305;p11"/>
           <p:cNvSpPr/>
           <p:nvPr/>
         </p:nvSpPr>
@@ -27419,7 +29343,7 @@
       </p:sp>
       <p:sp>
         <p:nvSpPr>
-          <p:cNvPr id="287" name="Google Shape;287;p11"/>
+          <p:cNvPr id="306" name="Google Shape;306;p11"/>
           <p:cNvSpPr/>
           <p:nvPr/>
         </p:nvSpPr>
@@ -27468,7 +29392,7 @@
       </p:sp>
       <p:sp>
         <p:nvSpPr>
-          <p:cNvPr id="288" name="Google Shape;288;p11"/>
+          <p:cNvPr id="307" name="Google Shape;307;p11"/>
           <p:cNvSpPr/>
           <p:nvPr/>
         </p:nvSpPr>
@@ -27530,7 +29454,7 @@
       </p:sp>
       <p:sp>
         <p:nvSpPr>
-          <p:cNvPr id="289" name="Google Shape;289;p11"/>
+          <p:cNvPr id="308" name="Google Shape;308;p11"/>
           <p:cNvSpPr/>
           <p:nvPr/>
         </p:nvSpPr>
@@ -27579,7 +29503,7 @@
       </p:sp>
       <p:sp>
         <p:nvSpPr>
-          <p:cNvPr id="290" name="Google Shape;290;p11"/>
+          <p:cNvPr id="309" name="Google Shape;309;p11"/>
           <p:cNvSpPr/>
           <p:nvPr/>
         </p:nvSpPr>
@@ -27628,7 +29552,7 @@
       </p:sp>
       <p:cxnSp>
         <p:nvCxnSpPr>
-          <p:cNvPr id="291" name="Google Shape;291;p11"/>
+          <p:cNvPr id="310" name="Google Shape;310;p11"/>
           <p:cNvCxnSpPr/>
           <p:nvPr/>
         </p:nvCxnSpPr>
@@ -27656,7 +29580,7 @@
       </p:cxnSp>
       <p:sp>
         <p:nvSpPr>
-          <p:cNvPr id="292" name="Google Shape;292;p11"/>
+          <p:cNvPr id="311" name="Google Shape;311;p11"/>
           <p:cNvSpPr/>
           <p:nvPr/>
         </p:nvSpPr>
@@ -27718,7 +29642,7 @@
       </p:sp>
       <p:sp>
         <p:nvSpPr>
-          <p:cNvPr id="293" name="Google Shape;293;p11"/>
+          <p:cNvPr id="312" name="Google Shape;312;p11"/>
           <p:cNvSpPr/>
           <p:nvPr/>
         </p:nvSpPr>
@@ -27767,7 +29691,7 @@
       </p:sp>
       <p:sp>
         <p:nvSpPr>
-          <p:cNvPr id="294" name="Google Shape;294;p11"/>
+          <p:cNvPr id="313" name="Google Shape;313;p11"/>
           <p:cNvSpPr/>
           <p:nvPr/>
         </p:nvSpPr>
@@ -27816,7 +29740,7 @@
       </p:sp>
       <p:pic>
         <p:nvPicPr>
-          <p:cNvPr id="295" name="Google Shape;295;p11"/>
+          <p:cNvPr id="314" name="Google Shape;314;p11"/>
           <p:cNvPicPr preferRelativeResize="0"/>
           <p:nvPr/>
         </p:nvPicPr>
@@ -27843,7 +29767,7 @@
       </p:pic>
       <p:sp>
         <p:nvSpPr>
-          <p:cNvPr id="296" name="Google Shape;296;p11"/>
+          <p:cNvPr id="315" name="Google Shape;315;p11"/>
           <p:cNvSpPr/>
           <p:nvPr/>
         </p:nvSpPr>
@@ -27905,9 +29829,9 @@
       </p:sp>
       <p:cxnSp>
         <p:nvCxnSpPr>
-          <p:cNvPr id="297" name="Google Shape;297;p11"/>
+          <p:cNvPr id="316" name="Google Shape;316;p11"/>
           <p:cNvCxnSpPr>
-            <a:endCxn id="292" idx="1"/>
+            <a:endCxn id="311" idx="1"/>
           </p:cNvCxnSpPr>
           <p:nvPr/>
         </p:nvCxnSpPr>
@@ -27935,10 +29859,10 @@
       </p:cxnSp>
       <p:cxnSp>
         <p:nvCxnSpPr>
-          <p:cNvPr id="298" name="Google Shape;298;p11"/>
+          <p:cNvPr id="317" name="Google Shape;317;p11"/>
           <p:cNvCxnSpPr>
-            <a:stCxn id="284" idx="6"/>
-            <a:endCxn id="292" idx="1"/>
+            <a:stCxn id="303" idx="6"/>
+            <a:endCxn id="311" idx="1"/>
           </p:cNvCxnSpPr>
           <p:nvPr/>
         </p:nvCxnSpPr>
@@ -27966,7 +29890,7 @@
       </p:cxnSp>
       <p:sp>
         <p:nvSpPr>
-          <p:cNvPr id="299" name="Google Shape;299;p11"/>
+          <p:cNvPr id="318" name="Google Shape;318;p11"/>
           <p:cNvSpPr/>
           <p:nvPr/>
         </p:nvSpPr>
@@ -28022,7 +29946,7 @@
       </p:sp>
       <p:sp>
         <p:nvSpPr>
-          <p:cNvPr id="300" name="Google Shape;300;p11"/>
+          <p:cNvPr id="319" name="Google Shape;319;p11"/>
           <p:cNvSpPr/>
           <p:nvPr/>
         </p:nvSpPr>
@@ -28071,7 +29995,7 @@
       </p:sp>
       <p:sp>
         <p:nvSpPr>
-          <p:cNvPr id="301" name="Google Shape;301;p11"/>
+          <p:cNvPr id="320" name="Google Shape;320;p11"/>
           <p:cNvSpPr/>
           <p:nvPr/>
         </p:nvSpPr>
@@ -28133,7 +30057,7 @@
       </p:sp>
       <p:sp>
         <p:nvSpPr>
-          <p:cNvPr id="302" name="Google Shape;302;p11"/>
+          <p:cNvPr id="321" name="Google Shape;321;p11"/>
           <p:cNvSpPr/>
           <p:nvPr/>
         </p:nvSpPr>
@@ -28195,7 +30119,7 @@
       </p:sp>
       <p:sp>
         <p:nvSpPr>
-          <p:cNvPr id="303" name="Google Shape;303;p11"/>
+          <p:cNvPr id="322" name="Google Shape;322;p11"/>
           <p:cNvSpPr/>
           <p:nvPr/>
         </p:nvSpPr>
@@ -28251,7 +30175,7 @@
       </p:sp>
       <p:sp>
         <p:nvSpPr>
-          <p:cNvPr id="304" name="Google Shape;304;p11"/>
+          <p:cNvPr id="323" name="Google Shape;323;p11"/>
           <p:cNvSpPr/>
           <p:nvPr/>
         </p:nvSpPr>
@@ -28300,7 +30224,7 @@
       </p:sp>
       <p:sp>
         <p:nvSpPr>
-          <p:cNvPr id="305" name="Google Shape;305;p11"/>
+          <p:cNvPr id="324" name="Google Shape;324;p11"/>
           <p:cNvSpPr/>
           <p:nvPr/>
         </p:nvSpPr>
@@ -28362,7 +30286,7 @@
       </p:sp>
       <p:sp>
         <p:nvSpPr>
-          <p:cNvPr id="306" name="Google Shape;306;p11"/>
+          <p:cNvPr id="325" name="Google Shape;325;p11"/>
           <p:cNvSpPr/>
           <p:nvPr/>
         </p:nvSpPr>
@@ -28424,7 +30348,7 @@
       </p:sp>
       <p:sp>
         <p:nvSpPr>
-          <p:cNvPr id="307" name="Google Shape;307;p11"/>
+          <p:cNvPr id="326" name="Google Shape;326;p11"/>
           <p:cNvSpPr/>
           <p:nvPr/>
         </p:nvSpPr>
@@ -28480,7 +30404,7 @@
       </p:sp>
       <p:sp>
         <p:nvSpPr>
-          <p:cNvPr id="308" name="Google Shape;308;p11"/>
+          <p:cNvPr id="327" name="Google Shape;327;p11"/>
           <p:cNvSpPr/>
           <p:nvPr/>
         </p:nvSpPr>
@@ -28529,7 +30453,7 @@
       </p:sp>
       <p:sp>
         <p:nvSpPr>
-          <p:cNvPr id="309" name="Google Shape;309;p11"/>
+          <p:cNvPr id="328" name="Google Shape;328;p11"/>
           <p:cNvSpPr/>
           <p:nvPr/>
         </p:nvSpPr>
@@ -28591,7 +30515,7 @@
       </p:sp>
       <p:sp>
         <p:nvSpPr>
-          <p:cNvPr id="310" name="Google Shape;310;p11"/>
+          <p:cNvPr id="329" name="Google Shape;329;p11"/>
           <p:cNvSpPr/>
           <p:nvPr/>
         </p:nvSpPr>
@@ -28660,6 +30584,285 @@
 </file>
 
 <file path=ppt/theme/theme1.xml><?xml version="1.0" encoding="utf-8"?>
+<a:theme xmlns:a="http://schemas.openxmlformats.org/drawingml/2006/main" xmlns:r="http://schemas.openxmlformats.org/officeDocument/2006/relationships" name="Office Theme">
+  <a:themeElements>
+    <a:clrScheme name="Office">
+      <a:dk1>
+        <a:srgbClr val="000000"/>
+      </a:dk1>
+      <a:lt1>
+        <a:srgbClr val="FFFFFF"/>
+      </a:lt1>
+      <a:dk2>
+        <a:srgbClr val="44546A"/>
+      </a:dk2>
+      <a:lt2>
+        <a:srgbClr val="E7E6E6"/>
+      </a:lt2>
+      <a:accent1>
+        <a:srgbClr val="4472C4"/>
+      </a:accent1>
+      <a:accent2>
+        <a:srgbClr val="ED7D31"/>
+      </a:accent2>
+      <a:accent3>
+        <a:srgbClr val="A5A5A5"/>
+      </a:accent3>
+      <a:accent4>
+        <a:srgbClr val="FFC000"/>
+      </a:accent4>
+      <a:accent5>
+        <a:srgbClr val="5B9BD5"/>
+      </a:accent5>
+      <a:accent6>
+        <a:srgbClr val="70AD47"/>
+      </a:accent6>
+      <a:hlink>
+        <a:srgbClr val="0563C1"/>
+      </a:hlink>
+      <a:folHlink>
+        <a:srgbClr val="954F72"/>
+      </a:folHlink>
+    </a:clrScheme>
+    <a:fontScheme name="Office">
+      <a:majorFont>
+        <a:latin typeface="Arial"/>
+        <a:ea typeface=""/>
+        <a:cs typeface=""/>
+        <a:font script="Jpan" typeface="ＭＳ Ｐゴシック"/>
+        <a:font script="Hang" typeface="맑은 고딕"/>
+        <a:font script="Hans" typeface="宋体"/>
+        <a:font script="Hant" typeface="新細明體"/>
+        <a:font script="Arab" typeface="Times New Roman"/>
+        <a:font script="Hebr" typeface="Times New Roman"/>
+        <a:font script="Thai" typeface="Angsana New"/>
+        <a:font script="Ethi" typeface="Nyala"/>
+        <a:font script="Beng" typeface="Vrinda"/>
+        <a:font script="Gujr" typeface="Shruti"/>
+        <a:font script="Khmr" typeface="MoolBoran"/>
+        <a:font script="Knda" typeface="Tunga"/>
+        <a:font script="Guru" typeface="Raavi"/>
+        <a:font script="Cans" typeface="Euphemia"/>
+        <a:font script="Cher" typeface="Plantagenet Cherokee"/>
+        <a:font script="Yiii" typeface="Microsoft Yi Baiti"/>
+        <a:font script="Tibt" typeface="Microsoft Himalaya"/>
+        <a:font script="Thaa" typeface="MV Boli"/>
+        <a:font script="Deva" typeface="Mangal"/>
+        <a:font script="Telu" typeface="Gautami"/>
+        <a:font script="Taml" typeface="Latha"/>
+        <a:font script="Syrc" typeface="Estrangelo Edessa"/>
+        <a:font script="Orya" typeface="Kalinga"/>
+        <a:font script="Mlym" typeface="Kartika"/>
+        <a:font script="Laoo" typeface="DokChampa"/>
+        <a:font script="Sinh" typeface="Iskoola Pota"/>
+        <a:font script="Mong" typeface="Mongolian Baiti"/>
+        <a:font script="Viet" typeface="Times New Roman"/>
+        <a:font script="Uigh" typeface="Microsoft Uighur"/>
+        <a:font script="Geor" typeface="Sylfaen"/>
+      </a:majorFont>
+      <a:minorFont>
+        <a:latin typeface="Arial"/>
+        <a:ea typeface=""/>
+        <a:cs typeface=""/>
+        <a:font script="Jpan" typeface="ＭＳ Ｐゴシック"/>
+        <a:font script="Hang" typeface="맑은 고딕"/>
+        <a:font script="Hans" typeface="宋体"/>
+        <a:font script="Hant" typeface="新細明體"/>
+        <a:font script="Arab" typeface="Arial"/>
+        <a:font script="Hebr" typeface="Arial"/>
+        <a:font script="Thai" typeface="Cordia New"/>
+        <a:font script="Ethi" typeface="Nyala"/>
+        <a:font script="Beng" typeface="Vrinda"/>
+        <a:font script="Gujr" typeface="Shruti"/>
+        <a:font script="Khmr" typeface="DaunPenh"/>
+        <a:font script="Knda" typeface="Tunga"/>
+        <a:font script="Guru" typeface="Raavi"/>
+        <a:font script="Cans" typeface="Euphemia"/>
+        <a:font script="Cher" typeface="Plantagenet Cherokee"/>
+        <a:font script="Yiii" typeface="Microsoft Yi Baiti"/>
+        <a:font script="Tibt" typeface="Microsoft Himalaya"/>
+        <a:font script="Thaa" typeface="MV Boli"/>
+        <a:font script="Deva" typeface="Mangal"/>
+        <a:font script="Telu" typeface="Gautami"/>
+        <a:font script="Taml" typeface="Latha"/>
+        <a:font script="Syrc" typeface="Estrangelo Edessa"/>
+        <a:font script="Orya" typeface="Kalinga"/>
+        <a:font script="Mlym" typeface="Kartika"/>
+        <a:font script="Laoo" typeface="DokChampa"/>
+        <a:font script="Sinh" typeface="Iskoola Pota"/>
+        <a:font script="Mong" typeface="Mongolian Baiti"/>
+        <a:font script="Viet" typeface="Arial"/>
+        <a:font script="Uigh" typeface="Microsoft Uighur"/>
+        <a:font script="Geor" typeface="Sylfaen"/>
+      </a:minorFont>
+    </a:fontScheme>
+    <a:fmtScheme name="Office">
+      <a:fillStyleLst>
+        <a:solidFill>
+          <a:schemeClr val="phClr"/>
+        </a:solidFill>
+        <a:gradFill rotWithShape="1">
+          <a:gsLst>
+            <a:gs pos="0">
+              <a:schemeClr val="phClr">
+                <a:tint val="50000"/>
+                <a:satMod val="300000"/>
+              </a:schemeClr>
+            </a:gs>
+            <a:gs pos="35000">
+              <a:schemeClr val="phClr">
+                <a:tint val="37000"/>
+                <a:satMod val="300000"/>
+              </a:schemeClr>
+            </a:gs>
+            <a:gs pos="100000">
+              <a:schemeClr val="phClr">
+                <a:tint val="15000"/>
+                <a:satMod val="350000"/>
+              </a:schemeClr>
+            </a:gs>
+          </a:gsLst>
+          <a:lin ang="16200000" scaled="1"/>
+        </a:gradFill>
+        <a:gradFill rotWithShape="1">
+          <a:gsLst>
+            <a:gs pos="0">
+              <a:schemeClr val="phClr">
+                <a:tint val="100000"/>
+                <a:shade val="100000"/>
+                <a:satMod val="130000"/>
+              </a:schemeClr>
+            </a:gs>
+            <a:gs pos="100000">
+              <a:schemeClr val="phClr">
+                <a:tint val="50000"/>
+                <a:shade val="100000"/>
+                <a:satMod val="350000"/>
+              </a:schemeClr>
+            </a:gs>
+          </a:gsLst>
+          <a:lin ang="16200000" scaled="0"/>
+        </a:gradFill>
+      </a:fillStyleLst>
+      <a:lnStyleLst>
+        <a:ln w="9525" cap="flat" cmpd="sng" algn="ctr">
+          <a:solidFill>
+            <a:schemeClr val="phClr">
+              <a:shade val="95000"/>
+              <a:satMod val="105000"/>
+            </a:schemeClr>
+          </a:solidFill>
+          <a:prstDash val="solid"/>
+        </a:ln>
+        <a:ln w="25400" cap="flat" cmpd="sng" algn="ctr">
+          <a:solidFill>
+            <a:schemeClr val="phClr"/>
+          </a:solidFill>
+          <a:prstDash val="solid"/>
+        </a:ln>
+        <a:ln w="38100" cap="flat" cmpd="sng" algn="ctr">
+          <a:solidFill>
+            <a:schemeClr val="phClr"/>
+          </a:solidFill>
+          <a:prstDash val="solid"/>
+        </a:ln>
+      </a:lnStyleLst>
+      <a:effectStyleLst>
+        <a:effectStyle>
+          <a:effectLst>
+            <a:outerShdw blurRad="40000" dist="20000" dir="5400000" rotWithShape="0">
+              <a:srgbClr val="000000">
+                <a:alpha val="38000"/>
+              </a:srgbClr>
+            </a:outerShdw>
+          </a:effectLst>
+        </a:effectStyle>
+        <a:effectStyle>
+          <a:effectLst>
+            <a:outerShdw blurRad="40000" dist="23000" dir="5400000" rotWithShape="0">
+              <a:srgbClr val="000000">
+                <a:alpha val="35000"/>
+              </a:srgbClr>
+            </a:outerShdw>
+          </a:effectLst>
+        </a:effectStyle>
+        <a:effectStyle>
+          <a:effectLst>
+            <a:outerShdw blurRad="40000" dist="23000" dir="5400000" rotWithShape="0">
+              <a:srgbClr val="000000">
+                <a:alpha val="35000"/>
+              </a:srgbClr>
+            </a:outerShdw>
+          </a:effectLst>
+          <a:scene3d>
+            <a:camera prst="orthographicFront">
+              <a:rot lat="0" lon="0" rev="0"/>
+            </a:camera>
+            <a:lightRig rig="threePt" dir="t">
+              <a:rot lat="0" lon="0" rev="1200000"/>
+            </a:lightRig>
+          </a:scene3d>
+          <a:sp3d>
+            <a:bevelT w="63500" h="25400"/>
+          </a:sp3d>
+        </a:effectStyle>
+      </a:effectStyleLst>
+      <a:bgFillStyleLst>
+        <a:solidFill>
+          <a:schemeClr val="phClr"/>
+        </a:solidFill>
+        <a:gradFill rotWithShape="1">
+          <a:gsLst>
+            <a:gs pos="0">
+              <a:schemeClr val="phClr">
+                <a:tint val="40000"/>
+                <a:satMod val="350000"/>
+              </a:schemeClr>
+            </a:gs>
+            <a:gs pos="40000">
+              <a:schemeClr val="phClr">
+                <a:tint val="45000"/>
+                <a:shade val="99000"/>
+                <a:satMod val="350000"/>
+              </a:schemeClr>
+            </a:gs>
+            <a:gs pos="100000">
+              <a:schemeClr val="phClr">
+                <a:shade val="20000"/>
+                <a:satMod val="255000"/>
+              </a:schemeClr>
+            </a:gs>
+          </a:gsLst>
+          <a:path path="circle">
+            <a:fillToRect l="50000" t="-80000" r="50000" b="180000"/>
+          </a:path>
+        </a:gradFill>
+        <a:gradFill rotWithShape="1">
+          <a:gsLst>
+            <a:gs pos="0">
+              <a:schemeClr val="phClr">
+                <a:tint val="80000"/>
+                <a:satMod val="300000"/>
+              </a:schemeClr>
+            </a:gs>
+            <a:gs pos="100000">
+              <a:schemeClr val="phClr">
+                <a:shade val="30000"/>
+                <a:satMod val="200000"/>
+              </a:schemeClr>
+            </a:gs>
+          </a:gsLst>
+          <a:path path="circle">
+            <a:fillToRect l="50000" t="50000" r="50000" b="50000"/>
+          </a:path>
+        </a:gradFill>
+      </a:bgFillStyleLst>
+    </a:fmtScheme>
+  </a:themeElements>
+</a:theme>
+</file>
+
+<file path=ppt/theme/theme2.xml><?xml version="1.0" encoding="utf-8"?>
 <a:theme xmlns:a="http://schemas.openxmlformats.org/drawingml/2006/main" xmlns:r="http://schemas.openxmlformats.org/officeDocument/2006/relationships">
   <a:themeElements>
     <a:clrScheme name="Default">
@@ -28936,283 +31139,4 @@
     </a:fmtScheme>
   </a:themeElements>
 </a:theme>
-</file>
-
-<file path=ppt/theme/theme2.xml><?xml version="1.0" encoding="utf-8"?>
-<a:theme xmlns:a="http://schemas.openxmlformats.org/drawingml/2006/main" xmlns:r="http://schemas.openxmlformats.org/officeDocument/2006/relationships" name="Office Theme">
-  <a:themeElements>
-    <a:clrScheme name="Office">
-      <a:dk1>
-        <a:srgbClr val="000000"/>
-      </a:dk1>
-      <a:lt1>
-        <a:srgbClr val="FFFFFF"/>
-      </a:lt1>
-      <a:dk2>
-        <a:srgbClr val="44546A"/>
-      </a:dk2>
-      <a:lt2>
-        <a:srgbClr val="E7E6E6"/>
-      </a:lt2>
-      <a:accent1>
-        <a:srgbClr val="4472C4"/>
-      </a:accent1>
-      <a:accent2>
-        <a:srgbClr val="ED7D31"/>
-      </a:accent2>
-      <a:accent3>
-        <a:srgbClr val="A5A5A5"/>
-      </a:accent3>
-      <a:accent4>
-        <a:srgbClr val="FFC000"/>
-      </a:accent4>
-      <a:accent5>
-        <a:srgbClr val="5B9BD5"/>
-      </a:accent5>
-      <a:accent6>
-        <a:srgbClr val="70AD47"/>
-      </a:accent6>
-      <a:hlink>
-        <a:srgbClr val="0563C1"/>
-      </a:hlink>
-      <a:folHlink>
-        <a:srgbClr val="954F72"/>
-      </a:folHlink>
-    </a:clrScheme>
-    <a:fontScheme name="Office">
-      <a:majorFont>
-        <a:latin typeface="Arial"/>
-        <a:ea typeface=""/>
-        <a:cs typeface=""/>
-        <a:font script="Jpan" typeface="ＭＳ Ｐゴシック"/>
-        <a:font script="Hang" typeface="맑은 고딕"/>
-        <a:font script="Hans" typeface="宋体"/>
-        <a:font script="Hant" typeface="新細明體"/>
-        <a:font script="Arab" typeface="Times New Roman"/>
-        <a:font script="Hebr" typeface="Times New Roman"/>
-        <a:font script="Thai" typeface="Angsana New"/>
-        <a:font script="Ethi" typeface="Nyala"/>
-        <a:font script="Beng" typeface="Vrinda"/>
-        <a:font script="Gujr" typeface="Shruti"/>
-        <a:font script="Khmr" typeface="MoolBoran"/>
-        <a:font script="Knda" typeface="Tunga"/>
-        <a:font script="Guru" typeface="Raavi"/>
-        <a:font script="Cans" typeface="Euphemia"/>
-        <a:font script="Cher" typeface="Plantagenet Cherokee"/>
-        <a:font script="Yiii" typeface="Microsoft Yi Baiti"/>
-        <a:font script="Tibt" typeface="Microsoft Himalaya"/>
-        <a:font script="Thaa" typeface="MV Boli"/>
-        <a:font script="Deva" typeface="Mangal"/>
-        <a:font script="Telu" typeface="Gautami"/>
-        <a:font script="Taml" typeface="Latha"/>
-        <a:font script="Syrc" typeface="Estrangelo Edessa"/>
-        <a:font script="Orya" typeface="Kalinga"/>
-        <a:font script="Mlym" typeface="Kartika"/>
-        <a:font script="Laoo" typeface="DokChampa"/>
-        <a:font script="Sinh" typeface="Iskoola Pota"/>
-        <a:font script="Mong" typeface="Mongolian Baiti"/>
-        <a:font script="Viet" typeface="Times New Roman"/>
-        <a:font script="Uigh" typeface="Microsoft Uighur"/>
-        <a:font script="Geor" typeface="Sylfaen"/>
-      </a:majorFont>
-      <a:minorFont>
-        <a:latin typeface="Arial"/>
-        <a:ea typeface=""/>
-        <a:cs typeface=""/>
-        <a:font script="Jpan" typeface="ＭＳ Ｐゴシック"/>
-        <a:font script="Hang" typeface="맑은 고딕"/>
-        <a:font script="Hans" typeface="宋体"/>
-        <a:font script="Hant" typeface="新細明體"/>
-        <a:font script="Arab" typeface="Arial"/>
-        <a:font script="Hebr" typeface="Arial"/>
-        <a:font script="Thai" typeface="Cordia New"/>
-        <a:font script="Ethi" typeface="Nyala"/>
-        <a:font script="Beng" typeface="Vrinda"/>
-        <a:font script="Gujr" typeface="Shruti"/>
-        <a:font script="Khmr" typeface="DaunPenh"/>
-        <a:font script="Knda" typeface="Tunga"/>
-        <a:font script="Guru" typeface="Raavi"/>
-        <a:font script="Cans" typeface="Euphemia"/>
-        <a:font script="Cher" typeface="Plantagenet Cherokee"/>
-        <a:font script="Yiii" typeface="Microsoft Yi Baiti"/>
-        <a:font script="Tibt" typeface="Microsoft Himalaya"/>
-        <a:font script="Thaa" typeface="MV Boli"/>
-        <a:font script="Deva" typeface="Mangal"/>
-        <a:font script="Telu" typeface="Gautami"/>
-        <a:font script="Taml" typeface="Latha"/>
-        <a:font script="Syrc" typeface="Estrangelo Edessa"/>
-        <a:font script="Orya" typeface="Kalinga"/>
-        <a:font script="Mlym" typeface="Kartika"/>
-        <a:font script="Laoo" typeface="DokChampa"/>
-        <a:font script="Sinh" typeface="Iskoola Pota"/>
-        <a:font script="Mong" typeface="Mongolian Baiti"/>
-        <a:font script="Viet" typeface="Arial"/>
-        <a:font script="Uigh" typeface="Microsoft Uighur"/>
-        <a:font script="Geor" typeface="Sylfaen"/>
-      </a:minorFont>
-    </a:fontScheme>
-    <a:fmtScheme name="Office">
-      <a:fillStyleLst>
-        <a:solidFill>
-          <a:schemeClr val="phClr"/>
-        </a:solidFill>
-        <a:gradFill rotWithShape="1">
-          <a:gsLst>
-            <a:gs pos="0">
-              <a:schemeClr val="phClr">
-                <a:tint val="50000"/>
-                <a:satMod val="300000"/>
-              </a:schemeClr>
-            </a:gs>
-            <a:gs pos="35000">
-              <a:schemeClr val="phClr">
-                <a:tint val="37000"/>
-                <a:satMod val="300000"/>
-              </a:schemeClr>
-            </a:gs>
-            <a:gs pos="100000">
-              <a:schemeClr val="phClr">
-                <a:tint val="15000"/>
-                <a:satMod val="350000"/>
-              </a:schemeClr>
-            </a:gs>
-          </a:gsLst>
-          <a:lin ang="16200000" scaled="1"/>
-        </a:gradFill>
-        <a:gradFill rotWithShape="1">
-          <a:gsLst>
-            <a:gs pos="0">
-              <a:schemeClr val="phClr">
-                <a:tint val="100000"/>
-                <a:shade val="100000"/>
-                <a:satMod val="130000"/>
-              </a:schemeClr>
-            </a:gs>
-            <a:gs pos="100000">
-              <a:schemeClr val="phClr">
-                <a:tint val="50000"/>
-                <a:shade val="100000"/>
-                <a:satMod val="350000"/>
-              </a:schemeClr>
-            </a:gs>
-          </a:gsLst>
-          <a:lin ang="16200000" scaled="0"/>
-        </a:gradFill>
-      </a:fillStyleLst>
-      <a:lnStyleLst>
-        <a:ln w="9525" cap="flat" cmpd="sng" algn="ctr">
-          <a:solidFill>
-            <a:schemeClr val="phClr">
-              <a:shade val="95000"/>
-              <a:satMod val="105000"/>
-            </a:schemeClr>
-          </a:solidFill>
-          <a:prstDash val="solid"/>
-        </a:ln>
-        <a:ln w="25400" cap="flat" cmpd="sng" algn="ctr">
-          <a:solidFill>
-            <a:schemeClr val="phClr"/>
-          </a:solidFill>
-          <a:prstDash val="solid"/>
-        </a:ln>
-        <a:ln w="38100" cap="flat" cmpd="sng" algn="ctr">
-          <a:solidFill>
-            <a:schemeClr val="phClr"/>
-          </a:solidFill>
-          <a:prstDash val="solid"/>
-        </a:ln>
-      </a:lnStyleLst>
-      <a:effectStyleLst>
-        <a:effectStyle>
-          <a:effectLst>
-            <a:outerShdw blurRad="40000" dist="20000" dir="5400000" rotWithShape="0">
-              <a:srgbClr val="000000">
-                <a:alpha val="38000"/>
-              </a:srgbClr>
-            </a:outerShdw>
-          </a:effectLst>
-        </a:effectStyle>
-        <a:effectStyle>
-          <a:effectLst>
-            <a:outerShdw blurRad="40000" dist="23000" dir="5400000" rotWithShape="0">
-              <a:srgbClr val="000000">
-                <a:alpha val="35000"/>
-              </a:srgbClr>
-            </a:outerShdw>
-          </a:effectLst>
-        </a:effectStyle>
-        <a:effectStyle>
-          <a:effectLst>
-            <a:outerShdw blurRad="40000" dist="23000" dir="5400000" rotWithShape="0">
-              <a:srgbClr val="000000">
-                <a:alpha val="35000"/>
-              </a:srgbClr>
-            </a:outerShdw>
-          </a:effectLst>
-          <a:scene3d>
-            <a:camera prst="orthographicFront">
-              <a:rot lat="0" lon="0" rev="0"/>
-            </a:camera>
-            <a:lightRig rig="threePt" dir="t">
-              <a:rot lat="0" lon="0" rev="1200000"/>
-            </a:lightRig>
-          </a:scene3d>
-          <a:sp3d>
-            <a:bevelT w="63500" h="25400"/>
-          </a:sp3d>
-        </a:effectStyle>
-      </a:effectStyleLst>
-      <a:bgFillStyleLst>
-        <a:solidFill>
-          <a:schemeClr val="phClr"/>
-        </a:solidFill>
-        <a:gradFill rotWithShape="1">
-          <a:gsLst>
-            <a:gs pos="0">
-              <a:schemeClr val="phClr">
-                <a:tint val="40000"/>
-                <a:satMod val="350000"/>
-              </a:schemeClr>
-            </a:gs>
-            <a:gs pos="40000">
-              <a:schemeClr val="phClr">
-                <a:tint val="45000"/>
-                <a:shade val="99000"/>
-                <a:satMod val="350000"/>
-              </a:schemeClr>
-            </a:gs>
-            <a:gs pos="100000">
-              <a:schemeClr val="phClr">
-                <a:shade val="20000"/>
-                <a:satMod val="255000"/>
-              </a:schemeClr>
-            </a:gs>
-          </a:gsLst>
-          <a:path path="circle">
-            <a:fillToRect l="50000" t="-80000" r="50000" b="180000"/>
-          </a:path>
-        </a:gradFill>
-        <a:gradFill rotWithShape="1">
-          <a:gsLst>
-            <a:gs pos="0">
-              <a:schemeClr val="phClr">
-                <a:tint val="80000"/>
-                <a:satMod val="300000"/>
-              </a:schemeClr>
-            </a:gs>
-            <a:gs pos="100000">
-              <a:schemeClr val="phClr">
-                <a:shade val="30000"/>
-                <a:satMod val="200000"/>
-              </a:schemeClr>
-            </a:gs>
-          </a:gsLst>
-          <a:path path="circle">
-            <a:fillToRect l="50000" t="50000" r="50000" b="50000"/>
-          </a:path>
-        </a:gradFill>
-      </a:bgFillStyleLst>
-    </a:fmtScheme>
-  </a:themeElements>
-</a:theme>
 </file>
</xml_diff>